<commit_message>
Subindo atualizações do TCC - Backend e Frontend
</commit_message>
<xml_diff>
--- a/Documentação/BANNER_TCC CIRCULARIS.pptx
+++ b/Documentação/BANNER_TCC CIRCULARIS.pptx
@@ -301,7 +301,7 @@
               <a:pPr>
                 <a:defRPr/>
               </a:pPr>
-              <a:t>13/11/2025</a:t>
+              <a:t>04/12/2025</a:t>
             </a:fld>
             <a:endParaRPr lang="pt-BR"/>
           </a:p>
@@ -4507,6 +4507,170 @@
       </p:grpSpPr>
       <p:sp>
         <p:nvSpPr>
+          <p:cNvPr id="4113" name="Text Box 146">
+            <a:extLst>
+              <a:ext uri="{FF2B5EF4-FFF2-40B4-BE49-F238E27FC236}">
+                <a16:creationId xmlns:a16="http://schemas.microsoft.com/office/drawing/2014/main" id="{D43F5D1D-A3D1-4155-BF51-6170C90B66CD}"/>
+              </a:ext>
+            </a:extLst>
+          </p:cNvPr>
+          <p:cNvSpPr txBox="1">
+            <a:spLocks noChangeArrowheads="1"/>
+          </p:cNvSpPr>
+          <p:nvPr/>
+        </p:nvSpPr>
+        <p:spPr bwMode="auto">
+          <a:xfrm>
+            <a:off x="-228600" y="-119100"/>
+            <a:ext cx="29032200" cy="5508625"/>
+          </a:xfrm>
+          <a:prstGeom prst="rect">
+            <a:avLst/>
+          </a:prstGeom>
+          <a:solidFill>
+            <a:srgbClr val="A90C0F"/>
+          </a:solidFill>
+          <a:ln w="9525">
+            <a:solidFill>
+              <a:srgbClr val="A90C0F"/>
+            </a:solidFill>
+            <a:miter lim="800000"/>
+            <a:headEnd/>
+            <a:tailEnd/>
+          </a:ln>
+          <a:effectLst>
+            <a:outerShdw dist="23000" dir="5400000" rotWithShape="0">
+              <a:srgbClr val="808080">
+                <a:alpha val="34998"/>
+              </a:srgbClr>
+            </a:outerShdw>
+          </a:effectLst>
+          <a:extLst/>
+        </p:spPr>
+        <p:txBody>
+          <a:bodyPr wrap="square" lIns="54462" tIns="27231" rIns="54462" bIns="27231">
+            <a:spAutoFit/>
+          </a:bodyPr>
+          <a:lstStyle>
+            <a:lvl1pPr defTabSz="544513">
+              <a:defRPr sz="2100">
+                <a:solidFill>
+                  <a:schemeClr val="tx1"/>
+                </a:solidFill>
+                <a:latin typeface="Times New Roman" panose="02020603050405020304" pitchFamily="18" charset="0"/>
+                <a:ea typeface="ＭＳ Ｐゴシック" panose="020B0600070205080204" pitchFamily="34" charset="-128"/>
+              </a:defRPr>
+            </a:lvl1pPr>
+            <a:lvl2pPr marL="742950" indent="-285750" defTabSz="544513">
+              <a:defRPr sz="2100">
+                <a:solidFill>
+                  <a:schemeClr val="tx1"/>
+                </a:solidFill>
+                <a:latin typeface="Times New Roman" panose="02020603050405020304" pitchFamily="18" charset="0"/>
+                <a:ea typeface="ＭＳ Ｐゴシック" panose="020B0600070205080204" pitchFamily="34" charset="-128"/>
+              </a:defRPr>
+            </a:lvl2pPr>
+            <a:lvl3pPr marL="1143000" indent="-228600" defTabSz="544513">
+              <a:defRPr sz="2100">
+                <a:solidFill>
+                  <a:schemeClr val="tx1"/>
+                </a:solidFill>
+                <a:latin typeface="Times New Roman" panose="02020603050405020304" pitchFamily="18" charset="0"/>
+                <a:ea typeface="ＭＳ Ｐゴシック" panose="020B0600070205080204" pitchFamily="34" charset="-128"/>
+              </a:defRPr>
+            </a:lvl3pPr>
+            <a:lvl4pPr marL="1600200" indent="-228600" defTabSz="544513">
+              <a:defRPr sz="2100">
+                <a:solidFill>
+                  <a:schemeClr val="tx1"/>
+                </a:solidFill>
+                <a:latin typeface="Times New Roman" panose="02020603050405020304" pitchFamily="18" charset="0"/>
+                <a:ea typeface="ＭＳ Ｐゴシック" panose="020B0600070205080204" pitchFamily="34" charset="-128"/>
+              </a:defRPr>
+            </a:lvl4pPr>
+            <a:lvl5pPr marL="2057400" indent="-228600" defTabSz="544513">
+              <a:defRPr sz="2100">
+                <a:solidFill>
+                  <a:schemeClr val="tx1"/>
+                </a:solidFill>
+                <a:latin typeface="Times New Roman" panose="02020603050405020304" pitchFamily="18" charset="0"/>
+                <a:ea typeface="ＭＳ Ｐゴシック" panose="020B0600070205080204" pitchFamily="34" charset="-128"/>
+              </a:defRPr>
+            </a:lvl5pPr>
+            <a:lvl6pPr marL="2514600" indent="-228600" defTabSz="544513" eaLnBrk="0" fontAlgn="base" hangingPunct="0">
+              <a:spcBef>
+                <a:spcPct val="0"/>
+              </a:spcBef>
+              <a:spcAft>
+                <a:spcPct val="0"/>
+              </a:spcAft>
+              <a:defRPr sz="2100">
+                <a:solidFill>
+                  <a:schemeClr val="tx1"/>
+                </a:solidFill>
+                <a:latin typeface="Times New Roman" panose="02020603050405020304" pitchFamily="18" charset="0"/>
+                <a:ea typeface="ＭＳ Ｐゴシック" panose="020B0600070205080204" pitchFamily="34" charset="-128"/>
+              </a:defRPr>
+            </a:lvl6pPr>
+            <a:lvl7pPr marL="2971800" indent="-228600" defTabSz="544513" eaLnBrk="0" fontAlgn="base" hangingPunct="0">
+              <a:spcBef>
+                <a:spcPct val="0"/>
+              </a:spcBef>
+              <a:spcAft>
+                <a:spcPct val="0"/>
+              </a:spcAft>
+              <a:defRPr sz="2100">
+                <a:solidFill>
+                  <a:schemeClr val="tx1"/>
+                </a:solidFill>
+                <a:latin typeface="Times New Roman" panose="02020603050405020304" pitchFamily="18" charset="0"/>
+                <a:ea typeface="ＭＳ Ｐゴシック" panose="020B0600070205080204" pitchFamily="34" charset="-128"/>
+              </a:defRPr>
+            </a:lvl7pPr>
+            <a:lvl8pPr marL="3429000" indent="-228600" defTabSz="544513" eaLnBrk="0" fontAlgn="base" hangingPunct="0">
+              <a:spcBef>
+                <a:spcPct val="0"/>
+              </a:spcBef>
+              <a:spcAft>
+                <a:spcPct val="0"/>
+              </a:spcAft>
+              <a:defRPr sz="2100">
+                <a:solidFill>
+                  <a:schemeClr val="tx1"/>
+                </a:solidFill>
+                <a:latin typeface="Times New Roman" panose="02020603050405020304" pitchFamily="18" charset="0"/>
+                <a:ea typeface="ＭＳ Ｐゴシック" panose="020B0600070205080204" pitchFamily="34" charset="-128"/>
+              </a:defRPr>
+            </a:lvl8pPr>
+            <a:lvl9pPr marL="3886200" indent="-228600" defTabSz="544513" eaLnBrk="0" fontAlgn="base" hangingPunct="0">
+              <a:spcBef>
+                <a:spcPct val="0"/>
+              </a:spcBef>
+              <a:spcAft>
+                <a:spcPct val="0"/>
+              </a:spcAft>
+              <a:defRPr sz="2100">
+                <a:solidFill>
+                  <a:schemeClr val="tx1"/>
+                </a:solidFill>
+                <a:latin typeface="Times New Roman" panose="02020603050405020304" pitchFamily="18" charset="0"/>
+                <a:ea typeface="ＭＳ Ｐゴシック" panose="020B0600070205080204" pitchFamily="34" charset="-128"/>
+              </a:defRPr>
+            </a:lvl9pPr>
+          </a:lstStyle>
+          <a:p>
+            <a:pPr algn="ctr"/>
+            <a:endParaRPr lang="en-US" altLang="pt-BR" sz="3600" dirty="0">
+              <a:solidFill>
+                <a:schemeClr val="bg1"/>
+              </a:solidFill>
+              <a:latin typeface="Verdana" panose="020B0604030504040204" pitchFamily="34" charset="0"/>
+            </a:endParaRPr>
+          </a:p>
+        </p:txBody>
+      </p:sp>
+      <p:sp>
+        <p:nvSpPr>
           <p:cNvPr id="4098" name="Text Box 147">
             <a:extLst>
               <a:ext uri="{FF2B5EF4-FFF2-40B4-BE49-F238E27FC236}">
@@ -4521,8 +4685,8 @@
         </p:nvSpPr>
         <p:spPr bwMode="auto">
           <a:xfrm>
-            <a:off x="1262061" y="7561529"/>
-            <a:ext cx="12239625" cy="3904954"/>
+            <a:off x="1395412" y="7806049"/>
+            <a:ext cx="12120563" cy="3135512"/>
           </a:xfrm>
           <a:prstGeom prst="rect">
             <a:avLst/>
@@ -4552,7 +4716,7 @@
           </a:extLst>
         </p:spPr>
         <p:txBody>
-          <a:bodyPr lIns="203531" tIns="89554" rIns="203531" bIns="89554">
+          <a:bodyPr wrap="square" lIns="203531" tIns="89554" rIns="203531" bIns="89554">
             <a:spAutoFit/>
           </a:bodyPr>
           <a:lstStyle>
@@ -4663,23 +4827,36 @@
             </a:lvl9pPr>
           </a:lstStyle>
           <a:p>
-            <a:r>
-              <a:rPr lang="pt-BR" altLang="pt-BR" sz="4200" kern="0" dirty="0">
+            <a:pPr algn="just"/>
+            <a:r>
+              <a:rPr lang="pt-BR" altLang="pt-BR" sz="3200" kern="0" dirty="0">
+                <a:latin typeface="Verdana" panose="020B0604030504040204" pitchFamily="34" charset="0"/>
+                <a:ea typeface="Verdana" panose="020B0604030504040204" pitchFamily="34" charset="0"/>
                 <a:cs typeface="Times New Roman" panose="02020603050405020304" pitchFamily="18" charset="0"/>
               </a:rPr>
               <a:t>O </a:t>
             </a:r>
             <a:r>
-              <a:rPr lang="pt-BR" altLang="pt-BR" sz="4200" kern="0" dirty="0" err="1">
+              <a:rPr lang="pt-BR" altLang="pt-BR" sz="3200" kern="0" dirty="0" err="1">
+                <a:latin typeface="Verdana" panose="020B0604030504040204" pitchFamily="34" charset="0"/>
+                <a:ea typeface="Verdana" panose="020B0604030504040204" pitchFamily="34" charset="0"/>
                 <a:cs typeface="Times New Roman" panose="02020603050405020304" pitchFamily="18" charset="0"/>
               </a:rPr>
               <a:t>Circularis</a:t>
             </a:r>
             <a:r>
-              <a:rPr lang="pt-BR" altLang="pt-BR" sz="4200" kern="0" dirty="0">
+              <a:rPr lang="pt-BR" altLang="pt-BR" sz="3200" kern="0" dirty="0">
+                <a:latin typeface="Verdana" panose="020B0604030504040204" pitchFamily="34" charset="0"/>
+                <a:ea typeface="Verdana" panose="020B0604030504040204" pitchFamily="34" charset="0"/>
                 <a:cs typeface="Times New Roman" panose="02020603050405020304" pitchFamily="18" charset="0"/>
               </a:rPr>
-              <a:t> é uma plataforma desenvolvida para incentivar práticas sustentáveis e a economia circular por meio da troca de livros e materiais entre usuários. O projeto busca fomentar o reaproveitamento e o compartilhamento consciente de recursos educacionais.</a:t>
+              <a:t> é uma plataforma desenvolvida para incentivar práticas sustentáveis e a economia circular por meio da troca de livros e materiais entre usuários. O projeto busca fomentar o reaproveitamento e o compartilhamento consciente de recursos educacionais</a:t>
+            </a:r>
+            <a:r>
+              <a:rPr lang="pt-BR" altLang="pt-BR" sz="3200" kern="0" dirty="0">
+                <a:cs typeface="Times New Roman" panose="02020603050405020304" pitchFamily="18" charset="0"/>
+              </a:rPr>
+              <a:t>.</a:t>
             </a:r>
           </a:p>
           <a:p>
@@ -4708,8 +4885,8 @@
         </p:nvSpPr>
         <p:spPr bwMode="auto">
           <a:xfrm>
-            <a:off x="1143000" y="33296522"/>
-            <a:ext cx="12239625" cy="5351503"/>
+            <a:off x="1333499" y="33896819"/>
+            <a:ext cx="12276785" cy="3627955"/>
           </a:xfrm>
           <a:prstGeom prst="rect">
             <a:avLst/>
@@ -4739,7 +4916,7 @@
           </a:extLst>
         </p:spPr>
         <p:txBody>
-          <a:bodyPr lIns="203531" tIns="89554" rIns="203531" bIns="89554">
+          <a:bodyPr wrap="square" lIns="203531" tIns="89554" rIns="203531" bIns="89554">
             <a:spAutoFit/>
           </a:bodyPr>
           <a:lstStyle>
@@ -4850,311 +5027,69 @@
             </a:lvl9pPr>
           </a:lstStyle>
           <a:p>
-            <a:r>
-              <a:rPr lang="pt-BR" sz="4200" dirty="0"/>
+            <a:pPr algn="just"/>
+            <a:r>
+              <a:rPr lang="pt-BR" sz="3200" dirty="0">
+                <a:latin typeface="Verdana" panose="020B0604030504040204" pitchFamily="34" charset="0"/>
+                <a:ea typeface="Verdana" panose="020B0604030504040204" pitchFamily="34" charset="0"/>
+              </a:rPr>
               <a:t>O desenvolvimento seguiu metodologia incremental e ágil, priorizando acessibilidade, segurança e usabilidade. A arquitetura do sistema é dividida em três camadas: </a:t>
             </a:r>
             <a:r>
-              <a:rPr lang="pt-BR" sz="4200" dirty="0" err="1"/>
+              <a:rPr lang="pt-BR" sz="3200" dirty="0" err="1">
+                <a:latin typeface="Verdana" panose="020B0604030504040204" pitchFamily="34" charset="0"/>
+                <a:ea typeface="Verdana" panose="020B0604030504040204" pitchFamily="34" charset="0"/>
+              </a:rPr>
               <a:t>frontend</a:t>
             </a:r>
             <a:r>
-              <a:rPr lang="pt-BR" sz="4200" dirty="0"/>
+              <a:rPr lang="pt-BR" sz="3200" dirty="0">
+                <a:latin typeface="Verdana" panose="020B0604030504040204" pitchFamily="34" charset="0"/>
+                <a:ea typeface="Verdana" panose="020B0604030504040204" pitchFamily="34" charset="0"/>
+              </a:rPr>
               <a:t> (</a:t>
             </a:r>
             <a:r>
-              <a:rPr lang="pt-BR" sz="4200" dirty="0" err="1"/>
+              <a:rPr lang="pt-BR" sz="3200" dirty="0" err="1">
+                <a:latin typeface="Verdana" panose="020B0604030504040204" pitchFamily="34" charset="0"/>
+                <a:ea typeface="Verdana" panose="020B0604030504040204" pitchFamily="34" charset="0"/>
+              </a:rPr>
               <a:t>React</a:t>
             </a:r>
             <a:r>
-              <a:rPr lang="pt-BR" sz="4200" dirty="0"/>
+              <a:rPr lang="pt-BR" sz="3200" dirty="0">
+                <a:latin typeface="Verdana" panose="020B0604030504040204" pitchFamily="34" charset="0"/>
+                <a:ea typeface="Verdana" panose="020B0604030504040204" pitchFamily="34" charset="0"/>
+              </a:rPr>
               <a:t> web e mobile), </a:t>
             </a:r>
             <a:r>
-              <a:rPr lang="pt-BR" sz="4200" dirty="0" err="1"/>
+              <a:rPr lang="pt-BR" sz="3200" dirty="0" err="1">
+                <a:latin typeface="Verdana" panose="020B0604030504040204" pitchFamily="34" charset="0"/>
+                <a:ea typeface="Verdana" panose="020B0604030504040204" pitchFamily="34" charset="0"/>
+              </a:rPr>
               <a:t>backend</a:t>
             </a:r>
             <a:r>
-              <a:rPr lang="pt-BR" sz="4200" dirty="0"/>
+              <a:rPr lang="pt-BR" sz="3200" dirty="0">
+                <a:latin typeface="Verdana" panose="020B0604030504040204" pitchFamily="34" charset="0"/>
+                <a:ea typeface="Verdana" panose="020B0604030504040204" pitchFamily="34" charset="0"/>
+              </a:rPr>
               <a:t> (API </a:t>
             </a:r>
             <a:r>
-              <a:rPr lang="pt-BR" sz="4200" dirty="0" err="1"/>
+              <a:rPr lang="pt-BR" sz="3200" dirty="0" err="1">
+                <a:latin typeface="Verdana" panose="020B0604030504040204" pitchFamily="34" charset="0"/>
+                <a:ea typeface="Verdana" panose="020B0604030504040204" pitchFamily="34" charset="0"/>
+              </a:rPr>
               <a:t>RESTful</a:t>
             </a:r>
             <a:r>
-              <a:rPr lang="pt-BR" sz="4200" dirty="0"/>
+              <a:rPr lang="pt-BR" sz="3200" dirty="0">
+                <a:latin typeface="Verdana" panose="020B0604030504040204" pitchFamily="34" charset="0"/>
+                <a:ea typeface="Verdana" panose="020B0604030504040204" pitchFamily="34" charset="0"/>
+              </a:rPr>
               <a:t> em Node.js) e banco de dados relacional (MySQL). Elementos de gamificação e notificações inteligentes foram implementados para engajamento dos usuários.</a:t>
-            </a:r>
-          </a:p>
-        </p:txBody>
-      </p:sp>
-      <p:sp>
-        <p:nvSpPr>
-          <p:cNvPr id="4100" name="Text Box 152">
-            <a:extLst>
-              <a:ext uri="{FF2B5EF4-FFF2-40B4-BE49-F238E27FC236}">
-                <a16:creationId xmlns:a16="http://schemas.microsoft.com/office/drawing/2014/main" id="{AA6A3FB8-74A7-486A-9690-3031AD0975CF}"/>
-              </a:ext>
-            </a:extLst>
-          </p:cNvPr>
-          <p:cNvSpPr txBox="1">
-            <a:spLocks noChangeArrowheads="1"/>
-          </p:cNvSpPr>
-          <p:nvPr/>
-        </p:nvSpPr>
-        <p:spPr bwMode="auto">
-          <a:xfrm>
-            <a:off x="15316200" y="33398429"/>
-            <a:ext cx="12239625" cy="5120671"/>
-          </a:xfrm>
-          <a:prstGeom prst="rect">
-            <a:avLst/>
-          </a:prstGeom>
-          <a:noFill/>
-          <a:ln>
-            <a:noFill/>
-          </a:ln>
-          <a:extLst>
-            <a:ext uri="{909E8E84-426E-40DD-AFC4-6F175D3DCCD1}">
-              <a14:hiddenFill xmlns:a14="http://schemas.microsoft.com/office/drawing/2010/main">
-                <a:solidFill>
-                  <a:srgbClr val="FFFFFF"/>
-                </a:solidFill>
-              </a14:hiddenFill>
-            </a:ext>
-            <a:ext uri="{91240B29-F687-4F45-9708-019B960494DF}">
-              <a14:hiddenLine xmlns:a14="http://schemas.microsoft.com/office/drawing/2010/main" w="57150" cmpd="thinThick">
-                <a:solidFill>
-                  <a:srgbClr val="000000"/>
-                </a:solidFill>
-                <a:miter lim="800000"/>
-                <a:headEnd/>
-                <a:tailEnd/>
-              </a14:hiddenLine>
-            </a:ext>
-          </a:extLst>
-        </p:spPr>
-        <p:txBody>
-          <a:bodyPr lIns="203531" tIns="89554" rIns="203531" bIns="89554">
-            <a:spAutoFit/>
-          </a:bodyPr>
-          <a:lstStyle>
-            <a:lvl1pPr>
-              <a:defRPr sz="2100">
-                <a:solidFill>
-                  <a:schemeClr val="tx1"/>
-                </a:solidFill>
-                <a:latin typeface="Times New Roman" panose="02020603050405020304" pitchFamily="18" charset="0"/>
-                <a:ea typeface="ＭＳ Ｐゴシック" panose="020B0600070205080204" pitchFamily="34" charset="-128"/>
-              </a:defRPr>
-            </a:lvl1pPr>
-            <a:lvl2pPr marL="742950" indent="-285750">
-              <a:defRPr sz="2100">
-                <a:solidFill>
-                  <a:schemeClr val="tx1"/>
-                </a:solidFill>
-                <a:latin typeface="Times New Roman" panose="02020603050405020304" pitchFamily="18" charset="0"/>
-                <a:ea typeface="ＭＳ Ｐゴシック" panose="020B0600070205080204" pitchFamily="34" charset="-128"/>
-              </a:defRPr>
-            </a:lvl2pPr>
-            <a:lvl3pPr marL="1143000" indent="-228600">
-              <a:defRPr sz="2100">
-                <a:solidFill>
-                  <a:schemeClr val="tx1"/>
-                </a:solidFill>
-                <a:latin typeface="Times New Roman" panose="02020603050405020304" pitchFamily="18" charset="0"/>
-                <a:ea typeface="ＭＳ Ｐゴシック" panose="020B0600070205080204" pitchFamily="34" charset="-128"/>
-              </a:defRPr>
-            </a:lvl3pPr>
-            <a:lvl4pPr marL="1600200" indent="-228600">
-              <a:defRPr sz="2100">
-                <a:solidFill>
-                  <a:schemeClr val="tx1"/>
-                </a:solidFill>
-                <a:latin typeface="Times New Roman" panose="02020603050405020304" pitchFamily="18" charset="0"/>
-                <a:ea typeface="ＭＳ Ｐゴシック" panose="020B0600070205080204" pitchFamily="34" charset="-128"/>
-              </a:defRPr>
-            </a:lvl4pPr>
-            <a:lvl5pPr marL="2057400" indent="-228600">
-              <a:defRPr sz="2100">
-                <a:solidFill>
-                  <a:schemeClr val="tx1"/>
-                </a:solidFill>
-                <a:latin typeface="Times New Roman" panose="02020603050405020304" pitchFamily="18" charset="0"/>
-                <a:ea typeface="ＭＳ Ｐゴシック" panose="020B0600070205080204" pitchFamily="34" charset="-128"/>
-              </a:defRPr>
-            </a:lvl5pPr>
-            <a:lvl6pPr marL="2514600" indent="-228600" eaLnBrk="0" fontAlgn="base" hangingPunct="0">
-              <a:spcBef>
-                <a:spcPct val="0"/>
-              </a:spcBef>
-              <a:spcAft>
-                <a:spcPct val="0"/>
-              </a:spcAft>
-              <a:defRPr sz="2100">
-                <a:solidFill>
-                  <a:schemeClr val="tx1"/>
-                </a:solidFill>
-                <a:latin typeface="Times New Roman" panose="02020603050405020304" pitchFamily="18" charset="0"/>
-                <a:ea typeface="ＭＳ Ｐゴシック" panose="020B0600070205080204" pitchFamily="34" charset="-128"/>
-              </a:defRPr>
-            </a:lvl6pPr>
-            <a:lvl7pPr marL="2971800" indent="-228600" eaLnBrk="0" fontAlgn="base" hangingPunct="0">
-              <a:spcBef>
-                <a:spcPct val="0"/>
-              </a:spcBef>
-              <a:spcAft>
-                <a:spcPct val="0"/>
-              </a:spcAft>
-              <a:defRPr sz="2100">
-                <a:solidFill>
-                  <a:schemeClr val="tx1"/>
-                </a:solidFill>
-                <a:latin typeface="Times New Roman" panose="02020603050405020304" pitchFamily="18" charset="0"/>
-                <a:ea typeface="ＭＳ Ｐゴシック" panose="020B0600070205080204" pitchFamily="34" charset="-128"/>
-              </a:defRPr>
-            </a:lvl7pPr>
-            <a:lvl8pPr marL="3429000" indent="-228600" eaLnBrk="0" fontAlgn="base" hangingPunct="0">
-              <a:spcBef>
-                <a:spcPct val="0"/>
-              </a:spcBef>
-              <a:spcAft>
-                <a:spcPct val="0"/>
-              </a:spcAft>
-              <a:defRPr sz="2100">
-                <a:solidFill>
-                  <a:schemeClr val="tx1"/>
-                </a:solidFill>
-                <a:latin typeface="Times New Roman" panose="02020603050405020304" pitchFamily="18" charset="0"/>
-                <a:ea typeface="ＭＳ Ｐゴシック" panose="020B0600070205080204" pitchFamily="34" charset="-128"/>
-              </a:defRPr>
-            </a:lvl8pPr>
-            <a:lvl9pPr marL="3886200" indent="-228600" eaLnBrk="0" fontAlgn="base" hangingPunct="0">
-              <a:spcBef>
-                <a:spcPct val="0"/>
-              </a:spcBef>
-              <a:spcAft>
-                <a:spcPct val="0"/>
-              </a:spcAft>
-              <a:defRPr sz="2100">
-                <a:solidFill>
-                  <a:schemeClr val="tx1"/>
-                </a:solidFill>
-                <a:latin typeface="Times New Roman" panose="02020603050405020304" pitchFamily="18" charset="0"/>
-                <a:ea typeface="ＭＳ Ｐゴシック" panose="020B0600070205080204" pitchFamily="34" charset="-128"/>
-              </a:defRPr>
-            </a:lvl9pPr>
-          </a:lstStyle>
-          <a:p>
-            <a:pPr marL="1440000"/>
-            <a:r>
-              <a:rPr lang="pt-BR" dirty="0"/>
-              <a:t>SOMMERVILLE, Ian. </a:t>
-            </a:r>
-            <a:r>
-              <a:rPr lang="pt-BR" b="1" dirty="0"/>
-              <a:t>Engenharia de Software</a:t>
-            </a:r>
-            <a:r>
-              <a:rPr lang="pt-BR" dirty="0"/>
-              <a:t>. Tradução de </a:t>
-            </a:r>
-            <a:r>
-              <a:rPr lang="pt-BR" dirty="0" err="1"/>
-              <a:t>Luis</a:t>
-            </a:r>
-            <a:r>
-              <a:rPr lang="pt-BR" dirty="0"/>
-              <a:t> Claudio Queiroz (Trad.). 10ª. ed. São Paulo: Pearson </a:t>
-            </a:r>
-            <a:r>
-              <a:rPr lang="pt-BR" dirty="0" err="1"/>
-              <a:t>Education</a:t>
-            </a:r>
-            <a:r>
-              <a:rPr lang="pt-BR" dirty="0"/>
-              <a:t> do Brasil, 2018. Disponível em: &lt;https://www.facom.ufu.br/~</a:t>
-            </a:r>
-            <a:r>
-              <a:rPr lang="pt-BR" dirty="0" err="1"/>
-              <a:t>william</a:t>
-            </a:r>
-            <a:r>
-              <a:rPr lang="pt-BR" dirty="0"/>
-              <a:t>/Disciplinas%202018-2/BSI-GSI030-EngenhariaSoftware/Livro/engenhariaSoftwareSommerville.pdf&gt;. Acesso em: 03 Outubro 2025.</a:t>
-            </a:r>
-          </a:p>
-          <a:p>
-            <a:pPr marL="1440000" algn="just"/>
-            <a:endParaRPr lang="en-US" altLang="pt-BR" sz="2400" dirty="0">
-              <a:solidFill>
-                <a:srgbClr val="000000"/>
-              </a:solidFill>
-              <a:latin typeface="Verdana" panose="020B0604030504040204" pitchFamily="34" charset="0"/>
-            </a:endParaRPr>
-          </a:p>
-          <a:p>
-            <a:pPr marL="1440000"/>
-            <a:r>
-              <a:rPr lang="pt-BR" dirty="0"/>
-              <a:t>VAZQUEZ, Carlos Eduardo; SILVA, José Roberto da. </a:t>
-            </a:r>
-            <a:r>
-              <a:rPr lang="pt-BR" b="1" dirty="0"/>
-              <a:t>Engenharia de Requisitos:</a:t>
-            </a:r>
-            <a:r>
-              <a:rPr lang="pt-BR" dirty="0"/>
-              <a:t> software orientado ao negócio. 2016. Rio de Janeiro, 2016. Disponível em: &lt;https://www.kufunda.net/</a:t>
-            </a:r>
-            <a:r>
-              <a:rPr lang="pt-BR" dirty="0" err="1"/>
-              <a:t>publicdocs</a:t>
-            </a:r>
-            <a:r>
-              <a:rPr lang="pt-BR" dirty="0"/>
-              <a:t>/Engenharia%20de%20Requisitos%20software%20orientado%20ao%20neg%C3%B3cio%20(Carlos%20Eduardo%20Vazquez%20etc.).</a:t>
-            </a:r>
-            <a:r>
-              <a:rPr lang="pt-BR" dirty="0" err="1"/>
-              <a:t>pdf</a:t>
-            </a:r>
-            <a:r>
-              <a:rPr lang="pt-BR" dirty="0"/>
-              <a:t>&gt;. Acesso em: 28 Outubro 2025.</a:t>
-            </a:r>
-          </a:p>
-          <a:p>
-            <a:pPr marL="1440000" algn="just"/>
-            <a:endParaRPr lang="en-US" altLang="pt-BR" sz="2400" dirty="0">
-              <a:solidFill>
-                <a:srgbClr val="000000"/>
-              </a:solidFill>
-              <a:latin typeface="Verdana" panose="020B0604030504040204" pitchFamily="34" charset="0"/>
-            </a:endParaRPr>
-          </a:p>
-          <a:p>
-            <a:pPr marL="1440000"/>
-            <a:r>
-              <a:rPr lang="pt-BR" dirty="0"/>
-              <a:t>PRESSMAN, Roger S.; MAXIM, Bruce R. </a:t>
-            </a:r>
-            <a:r>
-              <a:rPr lang="pt-BR" b="1" dirty="0"/>
-              <a:t>Engenharia de software:</a:t>
-            </a:r>
-            <a:r>
-              <a:rPr lang="pt-BR" dirty="0"/>
-              <a:t> uma abordagem profissional [recurso eletrônico]. 2021. Porto Alegre, 2021. Disponível em: &lt;https://analisederequisitos.com.br/</a:t>
-            </a:r>
-            <a:r>
-              <a:rPr lang="pt-BR" dirty="0" err="1"/>
-              <a:t>wp-content</a:t>
-            </a:r>
-            <a:r>
-              <a:rPr lang="pt-BR" dirty="0"/>
-              <a:t>/uploads/2024/02/engenharia-de-software-pressman-9-edicao-portugues.pdf&gt;. Acesso em: 30 Outubro 2025.</a:t>
             </a:r>
           </a:p>
         </p:txBody>
@@ -5175,8 +5110,8 @@
         </p:nvSpPr>
         <p:spPr bwMode="auto">
           <a:xfrm>
-            <a:off x="15316200" y="26879727"/>
-            <a:ext cx="12239625" cy="4705173"/>
+            <a:off x="14875858" y="26269086"/>
+            <a:ext cx="12239625" cy="3135512"/>
           </a:xfrm>
           <a:prstGeom prst="rect">
             <a:avLst/>
@@ -5317,23 +5252,29 @@
             </a:lvl9pPr>
           </a:lstStyle>
           <a:p>
-            <a:pPr>
+            <a:pPr algn="just">
               <a:defRPr/>
             </a:pPr>
             <a:r>
-              <a:rPr lang="pt-BR" altLang="pt-BR" sz="4200" kern="0" dirty="0">
+              <a:rPr lang="pt-BR" altLang="pt-BR" sz="3200" kern="0" dirty="0">
+                <a:latin typeface="Verdana" panose="020B0604030504040204" pitchFamily="34" charset="0"/>
+                <a:ea typeface="Verdana" panose="020B0604030504040204" pitchFamily="34" charset="0"/>
                 <a:cs typeface="Times New Roman" panose="02020603050405020304" pitchFamily="18" charset="0"/>
               </a:rPr>
               <a:t>O </a:t>
             </a:r>
             <a:r>
-              <a:rPr lang="pt-BR" altLang="pt-BR" sz="4200" kern="0" dirty="0" err="1">
+              <a:rPr lang="pt-BR" altLang="pt-BR" sz="3200" kern="0" dirty="0" err="1">
+                <a:latin typeface="Verdana" panose="020B0604030504040204" pitchFamily="34" charset="0"/>
+                <a:ea typeface="Verdana" panose="020B0604030504040204" pitchFamily="34" charset="0"/>
                 <a:cs typeface="Times New Roman" panose="02020603050405020304" pitchFamily="18" charset="0"/>
               </a:rPr>
               <a:t>Circularis</a:t>
             </a:r>
             <a:r>
-              <a:rPr lang="pt-BR" altLang="pt-BR" sz="4200" kern="0" dirty="0">
+              <a:rPr lang="pt-BR" altLang="pt-BR" sz="3200" kern="0" dirty="0">
+                <a:latin typeface="Verdana" panose="020B0604030504040204" pitchFamily="34" charset="0"/>
+                <a:ea typeface="Verdana" panose="020B0604030504040204" pitchFamily="34" charset="0"/>
                 <a:cs typeface="Times New Roman" panose="02020603050405020304" pitchFamily="18" charset="0"/>
               </a:rPr>
               <a:t> se destaca como solução inovadora para o setor educacional, promovendo sustentabilidade e acesso democrático ao conhecimento. Limitações técnicas impediram a implementação de serviços extras, como painéis administrativos avançados e módulos analíticos, que ficam como recomendações para trabalhos futuros.</a:t>
@@ -5357,8 +5298,8 @@
         </p:nvSpPr>
         <p:spPr bwMode="auto">
           <a:xfrm>
-            <a:off x="1262063" y="12823825"/>
-            <a:ext cx="12239625" cy="4058842"/>
+            <a:off x="1333499" y="13386111"/>
+            <a:ext cx="12182476" cy="3135512"/>
           </a:xfrm>
           <a:prstGeom prst="rect">
             <a:avLst/>
@@ -5388,7 +5329,7 @@
           </a:extLst>
         </p:spPr>
         <p:txBody>
-          <a:bodyPr lIns="203531" tIns="89554" rIns="203531" bIns="89554">
+          <a:bodyPr wrap="square" lIns="203531" tIns="89554" rIns="203531" bIns="89554">
             <a:spAutoFit/>
           </a:bodyPr>
           <a:lstStyle>
@@ -5499,68 +5440,87 @@
             </a:lvl9pPr>
           </a:lstStyle>
           <a:p>
-            <a:pPr>
+            <a:pPr algn="just">
               <a:defRPr/>
             </a:pPr>
             <a:r>
-              <a:rPr lang="pt-BR" altLang="pt-BR" sz="4200" kern="0" dirty="0">
+              <a:rPr lang="pt-BR" altLang="pt-BR" sz="3200" kern="0" dirty="0">
+                <a:latin typeface="Verdana" panose="020B0604030504040204" pitchFamily="34" charset="0"/>
+                <a:ea typeface="Verdana" panose="020B0604030504040204" pitchFamily="34" charset="0"/>
                 <a:cs typeface="Times New Roman" panose="02020603050405020304" pitchFamily="18" charset="0"/>
               </a:rPr>
               <a:t>O projeto utilizou técnicas de levantamento de requisitos, modelagem de processos e desenvolvimento ágil. Foram empregadas tecnologias como Node.js, </a:t>
             </a:r>
             <a:r>
-              <a:rPr lang="pt-BR" altLang="pt-BR" sz="4200" kern="0" dirty="0" err="1">
+              <a:rPr lang="pt-BR" altLang="pt-BR" sz="3200" kern="0" dirty="0" err="1">
+                <a:latin typeface="Verdana" panose="020B0604030504040204" pitchFamily="34" charset="0"/>
+                <a:ea typeface="Verdana" panose="020B0604030504040204" pitchFamily="34" charset="0"/>
                 <a:cs typeface="Times New Roman" panose="02020603050405020304" pitchFamily="18" charset="0"/>
               </a:rPr>
               <a:t>React</a:t>
             </a:r>
             <a:r>
-              <a:rPr lang="pt-BR" altLang="pt-BR" sz="4200" kern="0" dirty="0">
+              <a:rPr lang="pt-BR" altLang="pt-BR" sz="3200" kern="0" dirty="0">
+                <a:latin typeface="Verdana" panose="020B0604030504040204" pitchFamily="34" charset="0"/>
+                <a:ea typeface="Verdana" panose="020B0604030504040204" pitchFamily="34" charset="0"/>
                 <a:cs typeface="Times New Roman" panose="02020603050405020304" pitchFamily="18" charset="0"/>
               </a:rPr>
               <a:t> </a:t>
             </a:r>
             <a:r>
-              <a:rPr lang="pt-BR" altLang="pt-BR" sz="4200" kern="0" dirty="0" err="1">
+              <a:rPr lang="pt-BR" altLang="pt-BR" sz="3200" kern="0" dirty="0" err="1">
+                <a:latin typeface="Verdana" panose="020B0604030504040204" pitchFamily="34" charset="0"/>
+                <a:ea typeface="Verdana" panose="020B0604030504040204" pitchFamily="34" charset="0"/>
                 <a:cs typeface="Times New Roman" panose="02020603050405020304" pitchFamily="18" charset="0"/>
               </a:rPr>
               <a:t>Native</a:t>
             </a:r>
             <a:r>
-              <a:rPr lang="pt-BR" altLang="pt-BR" sz="4200" kern="0" dirty="0">
+              <a:rPr lang="pt-BR" altLang="pt-BR" sz="3200" kern="0" dirty="0">
+                <a:latin typeface="Verdana" panose="020B0604030504040204" pitchFamily="34" charset="0"/>
+                <a:ea typeface="Verdana" panose="020B0604030504040204" pitchFamily="34" charset="0"/>
                 <a:cs typeface="Times New Roman" panose="02020603050405020304" pitchFamily="18" charset="0"/>
               </a:rPr>
               <a:t>, e API REST, além da prototipação de interfaces no </a:t>
             </a:r>
             <a:r>
-              <a:rPr lang="pt-BR" altLang="pt-BR" sz="4200" kern="0" dirty="0" err="1">
+              <a:rPr lang="pt-BR" altLang="pt-BR" sz="3200" kern="0" dirty="0" err="1">
+                <a:latin typeface="Verdana" panose="020B0604030504040204" pitchFamily="34" charset="0"/>
+                <a:ea typeface="Verdana" panose="020B0604030504040204" pitchFamily="34" charset="0"/>
                 <a:cs typeface="Times New Roman" panose="02020603050405020304" pitchFamily="18" charset="0"/>
               </a:rPr>
               <a:t>Figma</a:t>
             </a:r>
             <a:r>
-              <a:rPr lang="pt-BR" altLang="pt-BR" sz="4200" kern="0" dirty="0">
+              <a:rPr lang="pt-BR" altLang="pt-BR" sz="3200" kern="0" dirty="0">
+                <a:latin typeface="Verdana" panose="020B0604030504040204" pitchFamily="34" charset="0"/>
+                <a:ea typeface="Verdana" panose="020B0604030504040204" pitchFamily="34" charset="0"/>
                 <a:cs typeface="Times New Roman" panose="02020603050405020304" pitchFamily="18" charset="0"/>
               </a:rPr>
               <a:t>. Testes e validações foram realizados com o apoio de ferramentas como </a:t>
             </a:r>
             <a:r>
-              <a:rPr lang="pt-BR" altLang="pt-BR" sz="4200" kern="0" dirty="0" err="1">
+              <a:rPr lang="pt-BR" altLang="pt-BR" sz="3200" kern="0" dirty="0" err="1">
+                <a:latin typeface="Verdana" panose="020B0604030504040204" pitchFamily="34" charset="0"/>
+                <a:ea typeface="Verdana" panose="020B0604030504040204" pitchFamily="34" charset="0"/>
                 <a:cs typeface="Times New Roman" panose="02020603050405020304" pitchFamily="18" charset="0"/>
               </a:rPr>
               <a:t>Postman</a:t>
             </a:r>
             <a:r>
-              <a:rPr lang="pt-BR" altLang="pt-BR" sz="4200" kern="0" dirty="0">
+              <a:rPr lang="pt-BR" altLang="pt-BR" sz="3200" kern="0" dirty="0">
+                <a:latin typeface="Verdana" panose="020B0604030504040204" pitchFamily="34" charset="0"/>
+                <a:ea typeface="Verdana" panose="020B0604030504040204" pitchFamily="34" charset="0"/>
                 <a:cs typeface="Times New Roman" panose="02020603050405020304" pitchFamily="18" charset="0"/>
               </a:rPr>
               <a:t>.</a:t>
             </a:r>
-            <a:endParaRPr lang="en-US" altLang="pt-BR" sz="4200" dirty="0">
+            <a:endParaRPr lang="en-US" altLang="pt-BR" sz="3200" dirty="0">
               <a:solidFill>
                 <a:srgbClr val="000000"/>
               </a:solidFill>
               <a:latin typeface="Verdana" panose="020B0604030504040204" pitchFamily="34" charset="0"/>
+              <a:ea typeface="Verdana" panose="020B0604030504040204" pitchFamily="34" charset="0"/>
             </a:endParaRPr>
           </a:p>
         </p:txBody>
@@ -5581,8 +5541,8 @@
         </p:nvSpPr>
         <p:spPr bwMode="auto">
           <a:xfrm>
-            <a:off x="1333500" y="6518589"/>
-            <a:ext cx="12001500" cy="728538"/>
+            <a:off x="1370659" y="6460483"/>
+            <a:ext cx="11964340" cy="697760"/>
           </a:xfrm>
           <a:prstGeom prst="rect">
             <a:avLst/>
@@ -5594,7 +5554,7 @@
           <a:effectLst/>
         </p:spPr>
         <p:txBody>
-          <a:bodyPr lIns="81412" tIns="40706" rIns="81412" bIns="40706">
+          <a:bodyPr wrap="square" lIns="81412" tIns="40706" rIns="81412" bIns="40706">
             <a:spAutoFit/>
           </a:bodyPr>
           <a:lstStyle>
@@ -5709,13 +5669,13 @@
               <a:defRPr/>
             </a:pPr>
             <a:r>
-              <a:rPr lang="en-US" sz="4200" b="1" cap="all" dirty="0">
+              <a:rPr lang="en-US" sz="4000" b="1" cap="all" dirty="0">
                 <a:solidFill>
                   <a:srgbClr val="CC0000"/>
                 </a:solidFill>
-                <a:latin typeface="+mj-lt"/>
-                <a:ea typeface="Verdana" pitchFamily="34" charset="0"/>
-                <a:cs typeface="Verdana" pitchFamily="34" charset="0"/>
+                <a:latin typeface="Verdana" panose="020B0604030504040204" pitchFamily="34" charset="0"/>
+                <a:ea typeface="Verdana" panose="020B0604030504040204" pitchFamily="34" charset="0"/>
+                <a:cs typeface="Verdana" panose="020B0604030504040204" pitchFamily="34" charset="0"/>
               </a:rPr>
               <a:t>INTRODUÇÃO</a:t>
             </a:r>
@@ -5738,8 +5698,8 @@
         </p:nvSpPr>
         <p:spPr bwMode="auto">
           <a:xfrm>
-            <a:off x="1262063" y="11636375"/>
-            <a:ext cx="12001500" cy="728538"/>
+            <a:off x="1370659" y="11906573"/>
+            <a:ext cx="12031980" cy="697760"/>
           </a:xfrm>
           <a:prstGeom prst="rect">
             <a:avLst/>
@@ -5751,7 +5711,7 @@
           <a:effectLst/>
         </p:spPr>
         <p:txBody>
-          <a:bodyPr lIns="81412" tIns="40706" rIns="81412" bIns="40706">
+          <a:bodyPr wrap="square" lIns="81412" tIns="40706" rIns="81412" bIns="40706">
             <a:spAutoFit/>
           </a:bodyPr>
           <a:lstStyle>
@@ -5866,13 +5826,13 @@
               <a:defRPr/>
             </a:pPr>
             <a:r>
-              <a:rPr lang="pt-BR" sz="4200" b="1" cap="all" dirty="0">
+              <a:rPr lang="pt-BR" sz="4000" b="1" cap="all" dirty="0">
                 <a:solidFill>
                   <a:srgbClr val="CC0000"/>
                 </a:solidFill>
-                <a:latin typeface="+mj-lt"/>
-                <a:ea typeface="Verdana" pitchFamily="34" charset="0"/>
-                <a:cs typeface="Verdana" pitchFamily="34" charset="0"/>
+                <a:latin typeface="Verdana" panose="020B0604030504040204" pitchFamily="34" charset="0"/>
+                <a:ea typeface="Verdana" panose="020B0604030504040204" pitchFamily="34" charset="0"/>
+                <a:cs typeface="Verdana" panose="020B0604030504040204" pitchFamily="34" charset="0"/>
               </a:rPr>
               <a:t>Metodologia</a:t>
             </a:r>
@@ -5895,8 +5855,8 @@
         </p:nvSpPr>
         <p:spPr bwMode="auto">
           <a:xfrm>
-            <a:off x="1295400" y="18348474"/>
-            <a:ext cx="11868150" cy="728538"/>
+            <a:off x="1370659" y="18499416"/>
+            <a:ext cx="11898630" cy="697760"/>
           </a:xfrm>
           <a:prstGeom prst="rect">
             <a:avLst/>
@@ -5908,7 +5868,7 @@
           <a:effectLst/>
         </p:spPr>
         <p:txBody>
-          <a:bodyPr lIns="81412" tIns="40706" rIns="81412" bIns="40706">
+          <a:bodyPr wrap="square" lIns="81412" tIns="40706" rIns="81412" bIns="40706">
             <a:spAutoFit/>
           </a:bodyPr>
           <a:lstStyle>
@@ -6023,13 +5983,13 @@
               <a:defRPr/>
             </a:pPr>
             <a:r>
-              <a:rPr lang="pt-BR" sz="4200" b="1" cap="all" noProof="1">
+              <a:rPr lang="pt-BR" sz="4000" b="1" cap="all" noProof="1">
                 <a:solidFill>
                   <a:srgbClr val="CC0000"/>
                 </a:solidFill>
-                <a:latin typeface="+mj-lt"/>
-                <a:ea typeface="Verdana" pitchFamily="34" charset="0"/>
-                <a:cs typeface="Verdana" pitchFamily="34" charset="0"/>
+                <a:latin typeface="Verdana" panose="020B0604030504040204" pitchFamily="34" charset="0"/>
+                <a:ea typeface="Verdana" panose="020B0604030504040204" pitchFamily="34" charset="0"/>
+                <a:cs typeface="Verdana" panose="020B0604030504040204" pitchFamily="34" charset="0"/>
               </a:rPr>
               <a:t>Desenvolvimento</a:t>
             </a:r>
@@ -6052,7 +6012,7 @@
         </p:nvSpPr>
         <p:spPr bwMode="auto">
           <a:xfrm>
-            <a:off x="15316200" y="25934987"/>
+            <a:off x="14875858" y="24933755"/>
             <a:ext cx="11601450" cy="696913"/>
           </a:xfrm>
           <a:prstGeom prst="rect">
@@ -6184,9 +6144,9 @@
                 <a:solidFill>
                   <a:srgbClr val="CC0000"/>
                 </a:solidFill>
-                <a:latin typeface="+mj-lt"/>
-                <a:ea typeface="Verdana" pitchFamily="34" charset="0"/>
-                <a:cs typeface="Verdana" pitchFamily="34" charset="0"/>
+                <a:latin typeface="Verdana" panose="020B0604030504040204" pitchFamily="34" charset="0"/>
+                <a:ea typeface="Verdana" panose="020B0604030504040204" pitchFamily="34" charset="0"/>
+                <a:cs typeface="Verdana" panose="020B0604030504040204" pitchFamily="34" charset="0"/>
               </a:rPr>
               <a:t>CONSIDERAÇÕES FINAIS</a:t>
             </a:r>
@@ -6209,8 +6169,8 @@
         </p:nvSpPr>
         <p:spPr bwMode="auto">
           <a:xfrm>
-            <a:off x="15316200" y="32109446"/>
-            <a:ext cx="11601450" cy="696912"/>
+            <a:off x="14875858" y="30441900"/>
+            <a:ext cx="11524858" cy="697760"/>
           </a:xfrm>
           <a:prstGeom prst="rect">
             <a:avLst/>
@@ -6222,7 +6182,7 @@
           <a:effectLst/>
         </p:spPr>
         <p:txBody>
-          <a:bodyPr lIns="81412" tIns="40706" rIns="81412" bIns="40706">
+          <a:bodyPr wrap="square" lIns="81412" tIns="40706" rIns="81412" bIns="40706">
             <a:spAutoFit/>
           </a:bodyPr>
           <a:lstStyle>
@@ -6341,9 +6301,9 @@
                 <a:solidFill>
                   <a:srgbClr val="CC0000"/>
                 </a:solidFill>
-                <a:latin typeface="+mj-lt"/>
-                <a:ea typeface="Verdana" pitchFamily="34" charset="0"/>
-                <a:cs typeface="Verdana" pitchFamily="34" charset="0"/>
+                <a:latin typeface="Verdana" panose="020B0604030504040204" pitchFamily="34" charset="0"/>
+                <a:ea typeface="Verdana" panose="020B0604030504040204" pitchFamily="34" charset="0"/>
+                <a:cs typeface="Verdana" panose="020B0604030504040204" pitchFamily="34" charset="0"/>
               </a:rPr>
               <a:t>Principais</a:t>
             </a:r>
@@ -6352,11 +6312,11 @@
                 <a:solidFill>
                   <a:srgbClr val="CC0000"/>
                 </a:solidFill>
-                <a:latin typeface="+mj-lt"/>
-                <a:ea typeface="Verdana" pitchFamily="34" charset="0"/>
-                <a:cs typeface="Verdana" pitchFamily="34" charset="0"/>
+                <a:latin typeface="Verdana" panose="020B0604030504040204" pitchFamily="34" charset="0"/>
+                <a:ea typeface="Verdana" panose="020B0604030504040204" pitchFamily="34" charset="0"/>
+                <a:cs typeface="Verdana" panose="020B0604030504040204" pitchFamily="34" charset="0"/>
               </a:rPr>
-              <a:t> REFERÊNCIAS BIBLIOGRÁFICAS</a:t>
+              <a:t> BIBLIOGRÁFICAS</a:t>
             </a:r>
           </a:p>
         </p:txBody>
@@ -6377,8 +6337,8 @@
         </p:nvSpPr>
         <p:spPr bwMode="auto">
           <a:xfrm>
-            <a:off x="15073705" y="10776429"/>
-            <a:ext cx="12239625" cy="9229488"/>
+            <a:off x="14785340" y="10288108"/>
+            <a:ext cx="12239625" cy="6582610"/>
           </a:xfrm>
           <a:prstGeom prst="rect">
             <a:avLst/>
@@ -6408,7 +6368,7 @@
           </a:extLst>
         </p:spPr>
         <p:txBody>
-          <a:bodyPr lIns="203531" tIns="89554" rIns="203531" bIns="89554">
+          <a:bodyPr wrap="square" lIns="203531" tIns="89554" rIns="203531" bIns="89554">
             <a:spAutoFit/>
           </a:bodyPr>
           <a:lstStyle>
@@ -6519,185 +6479,20 @@
             </a:lvl9pPr>
           </a:lstStyle>
           <a:p>
-            <a:r>
-              <a:rPr lang="pt-BR" sz="4200" dirty="0"/>
+            <a:pPr algn="just"/>
+            <a:r>
+              <a:rPr lang="pt-BR" sz="3200" dirty="0">
+                <a:latin typeface="Verdana" panose="020B0604030504040204" pitchFamily="34" charset="0"/>
+                <a:ea typeface="Verdana" panose="020B0604030504040204" pitchFamily="34" charset="0"/>
+              </a:rPr>
               <a:t>O projeto promove inclusão digital, sustentabilidade e economia circular, oferecendo uma solução técnica viável para comunidades em situação de vulnerabilidade social. Ao conectar usuários para o reuso consciente de materiais escolares, a plataforma contribui para a redução das desigualdades educacionais e sociais, estimulando a participação comunitária e a educação de qualidade. Além disso, ao utilizar tecnologias acessíveis e seguras, a solução fortalece a autonomia dos usuários, fomenta a economia circular e direciona o consumo consciente, alinhando-se aos Objetivos de Desenvolvimento Sustentável da ONU e promovendo transformação social e ambiental positiva.</a:t>
             </a:r>
-            <a:endParaRPr lang="en-US" altLang="pt-BR" sz="4200" dirty="0">
+            <a:endParaRPr lang="en-US" altLang="pt-BR" sz="3200" dirty="0">
               <a:solidFill>
                 <a:srgbClr val="000000"/>
               </a:solidFill>
               <a:latin typeface="Verdana" panose="020B0604030504040204" pitchFamily="34" charset="0"/>
-            </a:endParaRPr>
-          </a:p>
-        </p:txBody>
-      </p:sp>
-      <p:sp>
-        <p:nvSpPr>
-          <p:cNvPr id="4113" name="Text Box 146">
-            <a:extLst>
-              <a:ext uri="{FF2B5EF4-FFF2-40B4-BE49-F238E27FC236}">
-                <a16:creationId xmlns:a16="http://schemas.microsoft.com/office/drawing/2014/main" id="{D43F5D1D-A3D1-4155-BF51-6170C90B66CD}"/>
-              </a:ext>
-            </a:extLst>
-          </p:cNvPr>
-          <p:cNvSpPr txBox="1">
-            <a:spLocks noChangeArrowheads="1"/>
-          </p:cNvSpPr>
-          <p:nvPr/>
-        </p:nvSpPr>
-        <p:spPr bwMode="auto">
-          <a:xfrm>
-            <a:off x="-3175" y="-60325"/>
-            <a:ext cx="28803600" cy="5508625"/>
-          </a:xfrm>
-          <a:prstGeom prst="rect">
-            <a:avLst/>
-          </a:prstGeom>
-          <a:solidFill>
-            <a:srgbClr val="A90C0F"/>
-          </a:solidFill>
-          <a:ln>
-            <a:noFill/>
-          </a:ln>
-          <a:effectLst>
-            <a:outerShdw dist="23000" dir="5400000" rotWithShape="0">
-              <a:srgbClr val="808080">
-                <a:alpha val="34998"/>
-              </a:srgbClr>
-            </a:outerShdw>
-          </a:effectLst>
-          <a:extLst>
-            <a:ext uri="{91240B29-F687-4F45-9708-019B960494DF}">
-              <a14:hiddenLine xmlns:a14="http://schemas.microsoft.com/office/drawing/2010/main" w="9525">
-                <a:solidFill>
-                  <a:srgbClr val="000000"/>
-                </a:solidFill>
-                <a:miter lim="800000"/>
-                <a:headEnd/>
-                <a:tailEnd/>
-              </a14:hiddenLine>
-            </a:ext>
-          </a:extLst>
-        </p:spPr>
-        <p:txBody>
-          <a:bodyPr lIns="54462" tIns="27231" rIns="54462" bIns="27231">
-            <a:spAutoFit/>
-          </a:bodyPr>
-          <a:lstStyle>
-            <a:lvl1pPr defTabSz="544513">
-              <a:defRPr sz="2100">
-                <a:solidFill>
-                  <a:schemeClr val="tx1"/>
-                </a:solidFill>
-                <a:latin typeface="Times New Roman" panose="02020603050405020304" pitchFamily="18" charset="0"/>
-                <a:ea typeface="ＭＳ Ｐゴシック" panose="020B0600070205080204" pitchFamily="34" charset="-128"/>
-              </a:defRPr>
-            </a:lvl1pPr>
-            <a:lvl2pPr marL="742950" indent="-285750" defTabSz="544513">
-              <a:defRPr sz="2100">
-                <a:solidFill>
-                  <a:schemeClr val="tx1"/>
-                </a:solidFill>
-                <a:latin typeface="Times New Roman" panose="02020603050405020304" pitchFamily="18" charset="0"/>
-                <a:ea typeface="ＭＳ Ｐゴシック" panose="020B0600070205080204" pitchFamily="34" charset="-128"/>
-              </a:defRPr>
-            </a:lvl2pPr>
-            <a:lvl3pPr marL="1143000" indent="-228600" defTabSz="544513">
-              <a:defRPr sz="2100">
-                <a:solidFill>
-                  <a:schemeClr val="tx1"/>
-                </a:solidFill>
-                <a:latin typeface="Times New Roman" panose="02020603050405020304" pitchFamily="18" charset="0"/>
-                <a:ea typeface="ＭＳ Ｐゴシック" panose="020B0600070205080204" pitchFamily="34" charset="-128"/>
-              </a:defRPr>
-            </a:lvl3pPr>
-            <a:lvl4pPr marL="1600200" indent="-228600" defTabSz="544513">
-              <a:defRPr sz="2100">
-                <a:solidFill>
-                  <a:schemeClr val="tx1"/>
-                </a:solidFill>
-                <a:latin typeface="Times New Roman" panose="02020603050405020304" pitchFamily="18" charset="0"/>
-                <a:ea typeface="ＭＳ Ｐゴシック" panose="020B0600070205080204" pitchFamily="34" charset="-128"/>
-              </a:defRPr>
-            </a:lvl4pPr>
-            <a:lvl5pPr marL="2057400" indent="-228600" defTabSz="544513">
-              <a:defRPr sz="2100">
-                <a:solidFill>
-                  <a:schemeClr val="tx1"/>
-                </a:solidFill>
-                <a:latin typeface="Times New Roman" panose="02020603050405020304" pitchFamily="18" charset="0"/>
-                <a:ea typeface="ＭＳ Ｐゴシック" panose="020B0600070205080204" pitchFamily="34" charset="-128"/>
-              </a:defRPr>
-            </a:lvl5pPr>
-            <a:lvl6pPr marL="2514600" indent="-228600" defTabSz="544513" eaLnBrk="0" fontAlgn="base" hangingPunct="0">
-              <a:spcBef>
-                <a:spcPct val="0"/>
-              </a:spcBef>
-              <a:spcAft>
-                <a:spcPct val="0"/>
-              </a:spcAft>
-              <a:defRPr sz="2100">
-                <a:solidFill>
-                  <a:schemeClr val="tx1"/>
-                </a:solidFill>
-                <a:latin typeface="Times New Roman" panose="02020603050405020304" pitchFamily="18" charset="0"/>
-                <a:ea typeface="ＭＳ Ｐゴシック" panose="020B0600070205080204" pitchFamily="34" charset="-128"/>
-              </a:defRPr>
-            </a:lvl6pPr>
-            <a:lvl7pPr marL="2971800" indent="-228600" defTabSz="544513" eaLnBrk="0" fontAlgn="base" hangingPunct="0">
-              <a:spcBef>
-                <a:spcPct val="0"/>
-              </a:spcBef>
-              <a:spcAft>
-                <a:spcPct val="0"/>
-              </a:spcAft>
-              <a:defRPr sz="2100">
-                <a:solidFill>
-                  <a:schemeClr val="tx1"/>
-                </a:solidFill>
-                <a:latin typeface="Times New Roman" panose="02020603050405020304" pitchFamily="18" charset="0"/>
-                <a:ea typeface="ＭＳ Ｐゴシック" panose="020B0600070205080204" pitchFamily="34" charset="-128"/>
-              </a:defRPr>
-            </a:lvl7pPr>
-            <a:lvl8pPr marL="3429000" indent="-228600" defTabSz="544513" eaLnBrk="0" fontAlgn="base" hangingPunct="0">
-              <a:spcBef>
-                <a:spcPct val="0"/>
-              </a:spcBef>
-              <a:spcAft>
-                <a:spcPct val="0"/>
-              </a:spcAft>
-              <a:defRPr sz="2100">
-                <a:solidFill>
-                  <a:schemeClr val="tx1"/>
-                </a:solidFill>
-                <a:latin typeface="Times New Roman" panose="02020603050405020304" pitchFamily="18" charset="0"/>
-                <a:ea typeface="ＭＳ Ｐゴシック" panose="020B0600070205080204" pitchFamily="34" charset="-128"/>
-              </a:defRPr>
-            </a:lvl8pPr>
-            <a:lvl9pPr marL="3886200" indent="-228600" defTabSz="544513" eaLnBrk="0" fontAlgn="base" hangingPunct="0">
-              <a:spcBef>
-                <a:spcPct val="0"/>
-              </a:spcBef>
-              <a:spcAft>
-                <a:spcPct val="0"/>
-              </a:spcAft>
-              <a:defRPr sz="2100">
-                <a:solidFill>
-                  <a:schemeClr val="tx1"/>
-                </a:solidFill>
-                <a:latin typeface="Times New Roman" panose="02020603050405020304" pitchFamily="18" charset="0"/>
-                <a:ea typeface="ＭＳ Ｐゴシック" panose="020B0600070205080204" pitchFamily="34" charset="-128"/>
-              </a:defRPr>
-            </a:lvl9pPr>
-          </a:lstStyle>
-          <a:p>
-            <a:pPr algn="ctr"/>
-            <a:endParaRPr lang="en-US" altLang="pt-BR" sz="3600" dirty="0">
-              <a:solidFill>
-                <a:schemeClr val="bg1"/>
-              </a:solidFill>
-              <a:latin typeface="Verdana" panose="020B0604030504040204" pitchFamily="34" charset="0"/>
+              <a:ea typeface="Verdana" panose="020B0604030504040204" pitchFamily="34" charset="0"/>
             </a:endParaRPr>
           </a:p>
         </p:txBody>
@@ -6778,7 +6573,7 @@
         </p:nvSpPr>
         <p:spPr bwMode="auto">
           <a:xfrm>
-            <a:off x="1276350" y="1299819"/>
+            <a:off x="1395412" y="1241406"/>
             <a:ext cx="21675725" cy="1323439"/>
           </a:xfrm>
           <a:prstGeom prst="rect">
@@ -6920,12 +6715,13 @@
             </a:lvl9pPr>
           </a:lstStyle>
           <a:p>
-            <a:pPr algn="ctr"/>
             <a:r>
               <a:rPr lang="pt-BR" sz="4000" b="1" dirty="0">
                 <a:solidFill>
                   <a:schemeClr val="bg1"/>
                 </a:solidFill>
+                <a:latin typeface="Verdana" panose="020B0604030504040204" pitchFamily="34" charset="0"/>
+                <a:ea typeface="Verdana" panose="020B0604030504040204" pitchFamily="34" charset="0"/>
                 <a:cs typeface="Times New Roman" panose="02020603050405020304" pitchFamily="18" charset="0"/>
               </a:rPr>
               <a:t>Plataforma Colaborativa de Troca de Livros e Materiais Escolares: </a:t>
@@ -6935,6 +6731,8 @@
                 <a:solidFill>
                   <a:schemeClr val="bg1"/>
                 </a:solidFill>
+                <a:latin typeface="Verdana" panose="020B0604030504040204" pitchFamily="34" charset="0"/>
+                <a:ea typeface="Verdana" panose="020B0604030504040204" pitchFamily="34" charset="0"/>
                 <a:cs typeface="Times New Roman" panose="02020603050405020304" pitchFamily="18" charset="0"/>
               </a:rPr>
             </a:br>
@@ -6943,6 +6741,8 @@
                 <a:solidFill>
                   <a:schemeClr val="bg1"/>
                 </a:solidFill>
+                <a:latin typeface="Verdana" panose="020B0604030504040204" pitchFamily="34" charset="0"/>
+                <a:ea typeface="Verdana" panose="020B0604030504040204" pitchFamily="34" charset="0"/>
                 <a:cs typeface="Times New Roman" panose="02020603050405020304" pitchFamily="18" charset="0"/>
               </a:rPr>
               <a:t>Inclusão Digital e Sustentabilidade para uma Educação de Qualidade </a:t>
@@ -6952,6 +6752,7 @@
                 <a:schemeClr val="bg1"/>
               </a:solidFill>
               <a:latin typeface="Verdana" panose="020B0604030504040204" pitchFamily="34" charset="0"/>
+              <a:ea typeface="Verdana" panose="020B0604030504040204" pitchFamily="34" charset="0"/>
             </a:endParaRPr>
           </a:p>
         </p:txBody>
@@ -6972,8 +6773,8 @@
         </p:nvSpPr>
         <p:spPr bwMode="auto">
           <a:xfrm>
-            <a:off x="1276350" y="3314700"/>
-            <a:ext cx="20473988" cy="2086853"/>
+            <a:off x="1333499" y="3604917"/>
+            <a:ext cx="22117050" cy="1679627"/>
           </a:xfrm>
           <a:prstGeom prst="rect">
             <a:avLst/>
@@ -7120,65 +6921,72 @@
               </a:lnSpc>
             </a:pPr>
             <a:r>
-              <a:rPr lang="pt-BR" altLang="pt-BR" sz="3000" b="1" dirty="0">
+              <a:rPr lang="pt-BR" altLang="pt-BR" sz="2400" b="1" dirty="0">
                 <a:solidFill>
                   <a:schemeClr val="bg1"/>
                 </a:solidFill>
-                <a:latin typeface="+mj-lt"/>
+                <a:latin typeface="Verdana" panose="020B0604030504040204" pitchFamily="34" charset="0"/>
+                <a:ea typeface="Verdana" panose="020B0604030504040204" pitchFamily="34" charset="0"/>
               </a:rPr>
               <a:t>Curso</a:t>
             </a:r>
             <a:r>
-              <a:rPr lang="en-US" altLang="pt-BR" sz="3000" b="1" dirty="0">
+              <a:rPr lang="en-US" altLang="pt-BR" sz="2400" b="1" dirty="0">
                 <a:solidFill>
                   <a:schemeClr val="bg1"/>
                 </a:solidFill>
-                <a:latin typeface="+mj-lt"/>
+                <a:latin typeface="Verdana" panose="020B0604030504040204" pitchFamily="34" charset="0"/>
+                <a:ea typeface="Verdana" panose="020B0604030504040204" pitchFamily="34" charset="0"/>
               </a:rPr>
               <a:t>: Técnico </a:t>
             </a:r>
             <a:r>
-              <a:rPr lang="pt-BR" altLang="pt-BR" sz="3000" b="1" dirty="0">
+              <a:rPr lang="pt-BR" altLang="pt-BR" sz="2400" b="1" dirty="0">
                 <a:solidFill>
                   <a:schemeClr val="bg1"/>
                 </a:solidFill>
-                <a:latin typeface="+mj-lt"/>
+                <a:latin typeface="Verdana" panose="020B0604030504040204" pitchFamily="34" charset="0"/>
+                <a:ea typeface="Verdana" panose="020B0604030504040204" pitchFamily="34" charset="0"/>
               </a:rPr>
               <a:t>em</a:t>
             </a:r>
             <a:r>
-              <a:rPr lang="en-US" altLang="pt-BR" sz="3000" b="1" dirty="0">
+              <a:rPr lang="en-US" altLang="pt-BR" sz="2400" b="1" dirty="0">
                 <a:solidFill>
                   <a:schemeClr val="bg1"/>
                 </a:solidFill>
-                <a:latin typeface="+mj-lt"/>
+                <a:latin typeface="Verdana" panose="020B0604030504040204" pitchFamily="34" charset="0"/>
+                <a:ea typeface="Verdana" panose="020B0604030504040204" pitchFamily="34" charset="0"/>
               </a:rPr>
               <a:t> </a:t>
             </a:r>
             <a:r>
-              <a:rPr lang="pt-BR" altLang="pt-BR" sz="3000" b="1" dirty="0">
+              <a:rPr lang="pt-BR" altLang="pt-BR" sz="2400" b="1" dirty="0">
                 <a:solidFill>
                   <a:schemeClr val="bg1"/>
                 </a:solidFill>
-                <a:latin typeface="+mj-lt"/>
+                <a:latin typeface="Verdana" panose="020B0604030504040204" pitchFamily="34" charset="0"/>
+                <a:ea typeface="Verdana" panose="020B0604030504040204" pitchFamily="34" charset="0"/>
               </a:rPr>
               <a:t>Desenvolvimento</a:t>
             </a:r>
             <a:r>
-              <a:rPr lang="en-US" altLang="pt-BR" sz="3000" b="1" dirty="0">
+              <a:rPr lang="en-US" altLang="pt-BR" sz="2400" b="1" dirty="0">
                 <a:solidFill>
                   <a:schemeClr val="bg1"/>
                 </a:solidFill>
-                <a:latin typeface="+mj-lt"/>
+                <a:latin typeface="Verdana" panose="020B0604030504040204" pitchFamily="34" charset="0"/>
+                <a:ea typeface="Verdana" panose="020B0604030504040204" pitchFamily="34" charset="0"/>
               </a:rPr>
               <a:t> de </a:t>
             </a:r>
             <a:r>
-              <a:rPr lang="pt-BR" altLang="pt-BR" sz="3000" b="1" dirty="0">
+              <a:rPr lang="pt-BR" altLang="pt-BR" sz="2400" b="1" dirty="0">
                 <a:solidFill>
                   <a:schemeClr val="bg1"/>
                 </a:solidFill>
-                <a:latin typeface="+mj-lt"/>
+                <a:latin typeface="Verdana" panose="020B0604030504040204" pitchFamily="34" charset="0"/>
+                <a:ea typeface="Verdana" panose="020B0604030504040204" pitchFamily="34" charset="0"/>
               </a:rPr>
               <a:t>Sistemas</a:t>
             </a:r>
@@ -7190,56 +6998,42 @@
               </a:lnSpc>
             </a:pPr>
             <a:r>
-              <a:rPr lang="pt-BR" altLang="pt-BR" sz="3000" b="1" dirty="0">
+              <a:rPr lang="pt-BR" altLang="pt-BR" sz="2400" b="1" dirty="0">
                 <a:solidFill>
                   <a:schemeClr val="bg1"/>
                 </a:solidFill>
-                <a:latin typeface="+mj-lt"/>
+                <a:latin typeface="Verdana" panose="020B0604030504040204" pitchFamily="34" charset="0"/>
+                <a:ea typeface="Verdana" panose="020B0604030504040204" pitchFamily="34" charset="0"/>
               </a:rPr>
               <a:t>Orientador</a:t>
             </a:r>
             <a:r>
-              <a:rPr lang="en-US" altLang="pt-BR" sz="3000" b="1" dirty="0">
+              <a:rPr lang="en-US" altLang="pt-BR" sz="2400" b="1" dirty="0">
                 <a:solidFill>
                   <a:schemeClr val="bg1"/>
                 </a:solidFill>
-                <a:latin typeface="+mj-lt"/>
+                <a:latin typeface="Verdana" panose="020B0604030504040204" pitchFamily="34" charset="0"/>
+                <a:ea typeface="Verdana" panose="020B0604030504040204" pitchFamily="34" charset="0"/>
               </a:rPr>
-              <a:t>: Prof. XAVIER, </a:t>
-            </a:r>
-            <a:r>
-              <a:rPr lang="en-US" altLang="pt-BR" sz="3000" b="1" dirty="0" err="1">
+              <a:t>: Prof. XAVIER, Jefferson Alves </a:t>
+            </a:r>
+            <a:r>
+              <a:rPr lang="en-US" altLang="pt-BR" sz="2400" b="1" dirty="0" err="1">
                 <a:solidFill>
                   <a:schemeClr val="bg1"/>
                 </a:solidFill>
-                <a:latin typeface="+mj-lt"/>
-              </a:rPr>
-              <a:t>Jeferson</a:t>
-            </a:r>
-            <a:r>
-              <a:rPr lang="en-US" altLang="pt-BR" sz="3000" b="1" dirty="0">
-                <a:solidFill>
-                  <a:schemeClr val="bg1"/>
-                </a:solidFill>
-                <a:latin typeface="+mj-lt"/>
-              </a:rPr>
-              <a:t> Alves </a:t>
-            </a:r>
-            <a:r>
-              <a:rPr lang="en-US" altLang="pt-BR" sz="3000" b="1" dirty="0" err="1">
-                <a:solidFill>
-                  <a:schemeClr val="bg1"/>
-                </a:solidFill>
-                <a:latin typeface="+mj-lt"/>
+                <a:latin typeface="Verdana" panose="020B0604030504040204" pitchFamily="34" charset="0"/>
+                <a:ea typeface="Verdana" panose="020B0604030504040204" pitchFamily="34" charset="0"/>
               </a:rPr>
               <a:t>Brandão</a:t>
             </a:r>
             <a:r>
-              <a:rPr lang="en-US" altLang="pt-BR" sz="3000" b="1" dirty="0">
+              <a:rPr lang="en-US" altLang="pt-BR" sz="2400" b="1" dirty="0">
                 <a:solidFill>
                   <a:schemeClr val="bg1"/>
                 </a:solidFill>
-                <a:latin typeface="+mj-lt"/>
+                <a:latin typeface="Verdana" panose="020B0604030504040204" pitchFamily="34" charset="0"/>
+                <a:ea typeface="Verdana" panose="020B0604030504040204" pitchFamily="34" charset="0"/>
               </a:rPr>
               <a:t>.</a:t>
             </a:r>
@@ -7251,37 +7045,41 @@
               </a:lnSpc>
             </a:pPr>
             <a:r>
-              <a:rPr lang="pt-BR" altLang="pt-BR" sz="3000" b="1" dirty="0">
+              <a:rPr lang="pt-BR" altLang="pt-BR" sz="2400" b="1" dirty="0">
                 <a:solidFill>
                   <a:schemeClr val="bg1"/>
                 </a:solidFill>
-                <a:latin typeface="+mj-lt"/>
+                <a:latin typeface="Verdana" panose="020B0604030504040204" pitchFamily="34" charset="0"/>
+                <a:ea typeface="Verdana" panose="020B0604030504040204" pitchFamily="34" charset="0"/>
               </a:rPr>
               <a:t>Palavras-chave</a:t>
             </a:r>
             <a:r>
-              <a:rPr lang="en-US" altLang="pt-BR" sz="3000" b="1" dirty="0">
+              <a:rPr lang="en-US" altLang="pt-BR" sz="2400" b="1" dirty="0">
                 <a:solidFill>
                   <a:schemeClr val="bg1"/>
                 </a:solidFill>
-                <a:latin typeface="+mj-lt"/>
+                <a:latin typeface="Verdana" panose="020B0604030504040204" pitchFamily="34" charset="0"/>
+                <a:ea typeface="Verdana" panose="020B0604030504040204" pitchFamily="34" charset="0"/>
               </a:rPr>
               <a:t>: </a:t>
             </a:r>
             <a:r>
-              <a:rPr lang="pt-BR" altLang="pt-BR" sz="3000" dirty="0">
+              <a:rPr lang="pt-BR" altLang="pt-BR" sz="2400" dirty="0">
                 <a:solidFill>
                   <a:schemeClr val="bg1"/>
                 </a:solidFill>
-                <a:latin typeface="+mj-lt"/>
+                <a:latin typeface="Verdana" panose="020B0604030504040204" pitchFamily="34" charset="0"/>
+                <a:ea typeface="Verdana" panose="020B0604030504040204" pitchFamily="34" charset="0"/>
               </a:rPr>
               <a:t>inclusão digital; sustentabilidade; troca de materiais; educação de qualidade; economia circular</a:t>
             </a:r>
-            <a:endParaRPr lang="en-US" altLang="pt-BR" sz="3000" dirty="0">
+            <a:endParaRPr lang="en-US" altLang="pt-BR" sz="2400" dirty="0">
               <a:solidFill>
                 <a:schemeClr val="bg1"/>
               </a:solidFill>
-              <a:latin typeface="+mj-lt"/>
+              <a:latin typeface="Verdana" panose="020B0604030504040204" pitchFamily="34" charset="0"/>
+              <a:ea typeface="Verdana" panose="020B0604030504040204" pitchFamily="34" charset="0"/>
             </a:endParaRPr>
           </a:p>
         </p:txBody>
@@ -7302,8 +7100,8 @@
         </p:nvSpPr>
         <p:spPr bwMode="auto">
           <a:xfrm>
-            <a:off x="1314450" y="2746112"/>
-            <a:ext cx="17602200" cy="701859"/>
+            <a:off x="1333499" y="3086044"/>
+            <a:ext cx="21316950" cy="571631"/>
           </a:xfrm>
           <a:prstGeom prst="rect">
             <a:avLst/>
@@ -7333,7 +7131,7 @@
           </a:extLst>
         </p:spPr>
         <p:txBody>
-          <a:bodyPr>
+          <a:bodyPr wrap="square">
             <a:spAutoFit/>
           </a:bodyPr>
           <a:lstStyle>
@@ -7450,56 +7248,45 @@
               </a:lnSpc>
             </a:pPr>
             <a:r>
-              <a:rPr lang="pt-BR" altLang="pt-BR" sz="3000" b="1" dirty="0">
+              <a:rPr lang="pt-BR" altLang="pt-BR" sz="2400" b="1" dirty="0">
                 <a:solidFill>
                   <a:schemeClr val="bg1"/>
                 </a:solidFill>
-                <a:latin typeface="+mj-lt"/>
+                <a:latin typeface="Verdana" panose="020B0604030504040204" pitchFamily="34" charset="0"/>
+                <a:ea typeface="Verdana" panose="020B0604030504040204" pitchFamily="34" charset="0"/>
               </a:rPr>
               <a:t>Autores</a:t>
             </a:r>
             <a:r>
-              <a:rPr lang="en-US" altLang="pt-BR" sz="3000" b="1" dirty="0">
+              <a:rPr lang="en-US" altLang="pt-BR" sz="2400" b="1" dirty="0">
                 <a:solidFill>
                   <a:schemeClr val="bg1"/>
                 </a:solidFill>
-                <a:latin typeface="+mj-lt"/>
+                <a:latin typeface="Verdana" panose="020B0604030504040204" pitchFamily="34" charset="0"/>
+                <a:ea typeface="Verdana" panose="020B0604030504040204" pitchFamily="34" charset="0"/>
               </a:rPr>
-              <a:t>: SANTOS, Andréa Alves dos; NASCIMENTO, Caroline Dias do; CARMO, </a:t>
-            </a:r>
-            <a:r>
-              <a:rPr lang="en-US" altLang="pt-BR" sz="3000" b="1" dirty="0" err="1">
+              <a:t>: CARMO, </a:t>
+            </a:r>
+            <a:r>
+              <a:rPr lang="en-US" altLang="pt-BR" sz="2400" b="1" dirty="0" err="1">
                 <a:solidFill>
                   <a:schemeClr val="bg1"/>
                 </a:solidFill>
-                <a:latin typeface="+mj-lt"/>
+                <a:latin typeface="Verdana" panose="020B0604030504040204" pitchFamily="34" charset="0"/>
+                <a:ea typeface="Verdana" panose="020B0604030504040204" pitchFamily="34" charset="0"/>
               </a:rPr>
               <a:t>Raissa</a:t>
             </a:r>
             <a:r>
-              <a:rPr lang="en-US" altLang="pt-BR" sz="3000" b="1" dirty="0">
+              <a:rPr lang="en-US" altLang="pt-BR" sz="2400" b="1" dirty="0">
                 <a:solidFill>
                   <a:schemeClr val="bg1"/>
                 </a:solidFill>
-                <a:latin typeface="+mj-lt"/>
+                <a:latin typeface="Verdana" panose="020B0604030504040204" pitchFamily="34" charset="0"/>
+                <a:ea typeface="Verdana" panose="020B0604030504040204" pitchFamily="34" charset="0"/>
               </a:rPr>
-              <a:t> Chagas do</a:t>
-            </a:r>
-            <a:r>
-              <a:rPr lang="en-US" altLang="pt-BR" sz="2600" b="1" dirty="0">
-                <a:solidFill>
-                  <a:schemeClr val="bg1"/>
-                </a:solidFill>
-                <a:latin typeface="+mj-lt"/>
-              </a:rPr>
-              <a:t>.</a:t>
-            </a:r>
-            <a:endParaRPr lang="en-US" altLang="pt-BR" sz="2400" b="1" dirty="0">
-              <a:solidFill>
-                <a:schemeClr val="bg1"/>
-              </a:solidFill>
-              <a:latin typeface="Verdana" panose="020B0604030504040204" pitchFamily="34" charset="0"/>
-            </a:endParaRPr>
+              <a:t> Chagas do; NASCIMENTO, Caroline Dias do; SANTOS, Andréa Alves dos.</a:t>
+            </a:r>
           </a:p>
         </p:txBody>
       </p:sp>
@@ -7519,8 +7306,8 @@
         </p:nvSpPr>
         <p:spPr bwMode="auto">
           <a:xfrm>
-            <a:off x="1262062" y="19664363"/>
-            <a:ext cx="12239625" cy="5351503"/>
+            <a:off x="1333499" y="19664363"/>
+            <a:ext cx="12168188" cy="4120397"/>
           </a:xfrm>
           <a:prstGeom prst="rect">
             <a:avLst/>
@@ -7550,7 +7337,7 @@
           </a:extLst>
         </p:spPr>
         <p:txBody>
-          <a:bodyPr lIns="203531" tIns="89554" rIns="203531" bIns="89554">
+          <a:bodyPr wrap="square" lIns="203531" tIns="89554" rIns="203531" bIns="89554">
             <a:spAutoFit/>
           </a:bodyPr>
           <a:lstStyle>
@@ -7661,39 +7448,62 @@
             </a:lvl9pPr>
           </a:lstStyle>
           <a:p>
-            <a:r>
-              <a:rPr lang="pt-BR" sz="4200" dirty="0"/>
+            <a:pPr algn="just"/>
+            <a:r>
+              <a:rPr lang="pt-BR" sz="3200" dirty="0">
+                <a:latin typeface="Verdana" panose="020B0604030504040204" pitchFamily="34" charset="0"/>
+                <a:ea typeface="Verdana" panose="020B0604030504040204" pitchFamily="34" charset="0"/>
+              </a:rPr>
               <a:t>A </a:t>
             </a:r>
             <a:r>
-              <a:rPr lang="pt-BR" sz="4200" dirty="0" err="1"/>
+              <a:rPr lang="pt-BR" sz="3200" dirty="0" err="1">
+                <a:latin typeface="Verdana" panose="020B0604030504040204" pitchFamily="34" charset="0"/>
+                <a:ea typeface="Verdana" panose="020B0604030504040204" pitchFamily="34" charset="0"/>
+              </a:rPr>
               <a:t>Circularis</a:t>
             </a:r>
             <a:r>
-              <a:rPr lang="pt-BR" sz="4200" dirty="0"/>
+              <a:rPr lang="pt-BR" sz="3200" dirty="0">
+                <a:latin typeface="Verdana" panose="020B0604030504040204" pitchFamily="34" charset="0"/>
+                <a:ea typeface="Verdana" panose="020B0604030504040204" pitchFamily="34" charset="0"/>
+              </a:rPr>
               <a:t> é uma plataforma digital colaborativa, desenvolvida com tecnologias modernas como </a:t>
             </a:r>
             <a:r>
-              <a:rPr lang="pt-BR" sz="4200" dirty="0" err="1"/>
+              <a:rPr lang="pt-BR" sz="3200" dirty="0" err="1">
+                <a:latin typeface="Verdana" panose="020B0604030504040204" pitchFamily="34" charset="0"/>
+                <a:ea typeface="Verdana" panose="020B0604030504040204" pitchFamily="34" charset="0"/>
+              </a:rPr>
               <a:t>React</a:t>
             </a:r>
             <a:r>
-              <a:rPr lang="pt-BR" sz="4200" dirty="0"/>
+              <a:rPr lang="pt-BR" sz="3200" dirty="0">
+                <a:latin typeface="Verdana" panose="020B0604030504040204" pitchFamily="34" charset="0"/>
+                <a:ea typeface="Verdana" panose="020B0604030504040204" pitchFamily="34" charset="0"/>
+              </a:rPr>
               <a:t> </a:t>
             </a:r>
             <a:r>
-              <a:rPr lang="pt-BR" sz="4200" dirty="0" err="1"/>
+              <a:rPr lang="pt-BR" sz="3200" dirty="0" err="1">
+                <a:latin typeface="Verdana" panose="020B0604030504040204" pitchFamily="34" charset="0"/>
+                <a:ea typeface="Verdana" panose="020B0604030504040204" pitchFamily="34" charset="0"/>
+              </a:rPr>
               <a:t>Native</a:t>
             </a:r>
             <a:r>
-              <a:rPr lang="pt-BR" sz="4200" dirty="0"/>
+              <a:rPr lang="pt-BR" sz="3200" dirty="0">
+                <a:latin typeface="Verdana" panose="020B0604030504040204" pitchFamily="34" charset="0"/>
+                <a:ea typeface="Verdana" panose="020B0604030504040204" pitchFamily="34" charset="0"/>
+              </a:rPr>
               <a:t>, Node.js e MySQL, que facilita a troca e o reuso consciente de livros e materiais escolares. O sistema conta com funcionalidades essenciais como cadastro de usuários, filtragem e listagem de materiais, sistema de trocas, comunicação via chat interno e mecanismos de moderação.</a:t>
             </a:r>
-            <a:endParaRPr lang="en-US" altLang="pt-BR" sz="4200" dirty="0">
+            <a:endParaRPr lang="en-US" altLang="pt-BR" sz="3200" dirty="0">
               <a:solidFill>
                 <a:srgbClr val="000000"/>
               </a:solidFill>
               <a:latin typeface="Verdana" panose="020B0604030504040204" pitchFamily="34" charset="0"/>
+              <a:ea typeface="Verdana" panose="020B0604030504040204" pitchFamily="34" charset="0"/>
             </a:endParaRPr>
           </a:p>
         </p:txBody>
@@ -7774,8 +7584,8 @@
         </p:nvSpPr>
         <p:spPr bwMode="auto">
           <a:xfrm>
-            <a:off x="6877051" y="154935"/>
-            <a:ext cx="9277350" cy="1200329"/>
+            <a:off x="1371600" y="209371"/>
+            <a:ext cx="8505826" cy="1200329"/>
           </a:xfrm>
           <a:prstGeom prst="rect">
             <a:avLst/>
@@ -7916,13 +7726,13 @@
             </a:lvl9pPr>
           </a:lstStyle>
           <a:p>
-            <a:pPr algn="ctr"/>
             <a:r>
               <a:rPr lang="pt-BR" altLang="pt-BR" sz="7200" b="1" dirty="0">
                 <a:solidFill>
                   <a:schemeClr val="bg1"/>
                 </a:solidFill>
-                <a:latin typeface="Caprasimo" panose="0208090404030B020404" pitchFamily="18" charset="0"/>
+                <a:latin typeface="Verdana" panose="020B0604030504040204" pitchFamily="34" charset="0"/>
+                <a:ea typeface="Verdana" panose="020B0604030504040204" pitchFamily="34" charset="0"/>
                 <a:cs typeface="Times New Roman" panose="02020603050405020304" pitchFamily="18" charset="0"/>
               </a:rPr>
               <a:t>CIRCULARES</a:t>
@@ -7931,8 +7741,380 @@
               <a:solidFill>
                 <a:schemeClr val="bg1"/>
               </a:solidFill>
-              <a:latin typeface="Caprasimo" panose="0208090404030B020404" pitchFamily="18" charset="0"/>
+              <a:latin typeface="Verdana" panose="020B0604030504040204" pitchFamily="34" charset="0"/>
+              <a:ea typeface="Verdana" panose="020B0604030504040204" pitchFamily="34" charset="0"/>
             </a:endParaRPr>
+          </a:p>
+        </p:txBody>
+      </p:sp>
+      <p:pic>
+        <p:nvPicPr>
+          <p:cNvPr id="8" name="Imagem 7">
+            <a:extLst>
+              <a:ext uri="{FF2B5EF4-FFF2-40B4-BE49-F238E27FC236}">
+                <a16:creationId xmlns:a16="http://schemas.microsoft.com/office/drawing/2014/main" id="{3ABB98E4-819B-4723-9302-87447F20A7AF}"/>
+              </a:ext>
+            </a:extLst>
+          </p:cNvPr>
+          <p:cNvPicPr>
+            <a:picLocks noChangeAspect="1"/>
+          </p:cNvPicPr>
+          <p:nvPr/>
+        </p:nvPicPr>
+        <p:blipFill>
+          <a:blip r:embed="rId4">
+            <a:extLst>
+              <a:ext uri="{28A0092B-C50C-407E-A947-70E740481C1C}">
+                <a14:useLocalDpi xmlns:a14="http://schemas.microsoft.com/office/drawing/2010/main" val="0"/>
+              </a:ext>
+            </a:extLst>
+          </a:blip>
+          <a:stretch>
+            <a:fillRect/>
+          </a:stretch>
+        </p:blipFill>
+        <p:spPr>
+          <a:xfrm>
+            <a:off x="15726940" y="5872031"/>
+            <a:ext cx="9899285" cy="4197731"/>
+          </a:xfrm>
+          <a:prstGeom prst="rect">
+            <a:avLst/>
+          </a:prstGeom>
+        </p:spPr>
+      </p:pic>
+      <p:sp>
+        <p:nvSpPr>
+          <p:cNvPr id="4100" name="Text Box 152">
+            <a:extLst>
+              <a:ext uri="{FF2B5EF4-FFF2-40B4-BE49-F238E27FC236}">
+                <a16:creationId xmlns:a16="http://schemas.microsoft.com/office/drawing/2014/main" id="{AA6A3FB8-74A7-486A-9690-3031AD0975CF}"/>
+              </a:ext>
+            </a:extLst>
+          </p:cNvPr>
+          <p:cNvSpPr txBox="1">
+            <a:spLocks noChangeArrowheads="1"/>
+          </p:cNvSpPr>
+          <p:nvPr/>
+        </p:nvSpPr>
+        <p:spPr bwMode="auto">
+          <a:xfrm>
+            <a:off x="15031646" y="31678795"/>
+            <a:ext cx="11993319" cy="8306158"/>
+          </a:xfrm>
+          <a:prstGeom prst="rect">
+            <a:avLst/>
+          </a:prstGeom>
+          <a:noFill/>
+          <a:ln>
+            <a:noFill/>
+          </a:ln>
+          <a:extLst>
+            <a:ext uri="{909E8E84-426E-40DD-AFC4-6F175D3DCCD1}">
+              <a14:hiddenFill xmlns:a14="http://schemas.microsoft.com/office/drawing/2010/main">
+                <a:solidFill>
+                  <a:srgbClr val="FFFFFF"/>
+                </a:solidFill>
+              </a14:hiddenFill>
+            </a:ext>
+            <a:ext uri="{91240B29-F687-4F45-9708-019B960494DF}">
+              <a14:hiddenLine xmlns:a14="http://schemas.microsoft.com/office/drawing/2010/main" w="57150" cmpd="thinThick">
+                <a:solidFill>
+                  <a:srgbClr val="000000"/>
+                </a:solidFill>
+                <a:miter lim="800000"/>
+                <a:headEnd/>
+                <a:tailEnd/>
+              </a14:hiddenLine>
+            </a:ext>
+          </a:extLst>
+        </p:spPr>
+        <p:txBody>
+          <a:bodyPr wrap="square" lIns="203531" tIns="89554" rIns="203531" bIns="89554">
+            <a:spAutoFit/>
+          </a:bodyPr>
+          <a:lstStyle>
+            <a:lvl1pPr>
+              <a:defRPr sz="2100">
+                <a:solidFill>
+                  <a:schemeClr val="tx1"/>
+                </a:solidFill>
+                <a:latin typeface="Times New Roman" panose="02020603050405020304" pitchFamily="18" charset="0"/>
+                <a:ea typeface="ＭＳ Ｐゴシック" panose="020B0600070205080204" pitchFamily="34" charset="-128"/>
+              </a:defRPr>
+            </a:lvl1pPr>
+            <a:lvl2pPr marL="742950" indent="-285750">
+              <a:defRPr sz="2100">
+                <a:solidFill>
+                  <a:schemeClr val="tx1"/>
+                </a:solidFill>
+                <a:latin typeface="Times New Roman" panose="02020603050405020304" pitchFamily="18" charset="0"/>
+                <a:ea typeface="ＭＳ Ｐゴシック" panose="020B0600070205080204" pitchFamily="34" charset="-128"/>
+              </a:defRPr>
+            </a:lvl2pPr>
+            <a:lvl3pPr marL="1143000" indent="-228600">
+              <a:defRPr sz="2100">
+                <a:solidFill>
+                  <a:schemeClr val="tx1"/>
+                </a:solidFill>
+                <a:latin typeface="Times New Roman" panose="02020603050405020304" pitchFamily="18" charset="0"/>
+                <a:ea typeface="ＭＳ Ｐゴシック" panose="020B0600070205080204" pitchFamily="34" charset="-128"/>
+              </a:defRPr>
+            </a:lvl3pPr>
+            <a:lvl4pPr marL="1600200" indent="-228600">
+              <a:defRPr sz="2100">
+                <a:solidFill>
+                  <a:schemeClr val="tx1"/>
+                </a:solidFill>
+                <a:latin typeface="Times New Roman" panose="02020603050405020304" pitchFamily="18" charset="0"/>
+                <a:ea typeface="ＭＳ Ｐゴシック" panose="020B0600070205080204" pitchFamily="34" charset="-128"/>
+              </a:defRPr>
+            </a:lvl4pPr>
+            <a:lvl5pPr marL="2057400" indent="-228600">
+              <a:defRPr sz="2100">
+                <a:solidFill>
+                  <a:schemeClr val="tx1"/>
+                </a:solidFill>
+                <a:latin typeface="Times New Roman" panose="02020603050405020304" pitchFamily="18" charset="0"/>
+                <a:ea typeface="ＭＳ Ｐゴシック" panose="020B0600070205080204" pitchFamily="34" charset="-128"/>
+              </a:defRPr>
+            </a:lvl5pPr>
+            <a:lvl6pPr marL="2514600" indent="-228600" eaLnBrk="0" fontAlgn="base" hangingPunct="0">
+              <a:spcBef>
+                <a:spcPct val="0"/>
+              </a:spcBef>
+              <a:spcAft>
+                <a:spcPct val="0"/>
+              </a:spcAft>
+              <a:defRPr sz="2100">
+                <a:solidFill>
+                  <a:schemeClr val="tx1"/>
+                </a:solidFill>
+                <a:latin typeface="Times New Roman" panose="02020603050405020304" pitchFamily="18" charset="0"/>
+                <a:ea typeface="ＭＳ Ｐゴシック" panose="020B0600070205080204" pitchFamily="34" charset="-128"/>
+              </a:defRPr>
+            </a:lvl6pPr>
+            <a:lvl7pPr marL="2971800" indent="-228600" eaLnBrk="0" fontAlgn="base" hangingPunct="0">
+              <a:spcBef>
+                <a:spcPct val="0"/>
+              </a:spcBef>
+              <a:spcAft>
+                <a:spcPct val="0"/>
+              </a:spcAft>
+              <a:defRPr sz="2100">
+                <a:solidFill>
+                  <a:schemeClr val="tx1"/>
+                </a:solidFill>
+                <a:latin typeface="Times New Roman" panose="02020603050405020304" pitchFamily="18" charset="0"/>
+                <a:ea typeface="ＭＳ Ｐゴシック" panose="020B0600070205080204" pitchFamily="34" charset="-128"/>
+              </a:defRPr>
+            </a:lvl7pPr>
+            <a:lvl8pPr marL="3429000" indent="-228600" eaLnBrk="0" fontAlgn="base" hangingPunct="0">
+              <a:spcBef>
+                <a:spcPct val="0"/>
+              </a:spcBef>
+              <a:spcAft>
+                <a:spcPct val="0"/>
+              </a:spcAft>
+              <a:defRPr sz="2100">
+                <a:solidFill>
+                  <a:schemeClr val="tx1"/>
+                </a:solidFill>
+                <a:latin typeface="Times New Roman" panose="02020603050405020304" pitchFamily="18" charset="0"/>
+                <a:ea typeface="ＭＳ Ｐゴシック" panose="020B0600070205080204" pitchFamily="34" charset="-128"/>
+              </a:defRPr>
+            </a:lvl8pPr>
+            <a:lvl9pPr marL="3886200" indent="-228600" eaLnBrk="0" fontAlgn="base" hangingPunct="0">
+              <a:spcBef>
+                <a:spcPct val="0"/>
+              </a:spcBef>
+              <a:spcAft>
+                <a:spcPct val="0"/>
+              </a:spcAft>
+              <a:defRPr sz="2100">
+                <a:solidFill>
+                  <a:schemeClr val="tx1"/>
+                </a:solidFill>
+                <a:latin typeface="Times New Roman" panose="02020603050405020304" pitchFamily="18" charset="0"/>
+                <a:ea typeface="ＭＳ Ｐゴシック" panose="020B0600070205080204" pitchFamily="34" charset="-128"/>
+              </a:defRPr>
+            </a:lvl9pPr>
+          </a:lstStyle>
+          <a:p>
+            <a:pPr marL="1440000" algn="just"/>
+            <a:r>
+              <a:rPr lang="pt-BR" sz="2400" dirty="0">
+                <a:latin typeface="Verdana" panose="020B0604030504040204" pitchFamily="34" charset="0"/>
+                <a:ea typeface="Verdana" panose="020B0604030504040204" pitchFamily="34" charset="0"/>
+              </a:rPr>
+              <a:t>SOMMERVILLE, Ian. </a:t>
+            </a:r>
+            <a:r>
+              <a:rPr lang="pt-BR" sz="2400" b="1" dirty="0">
+                <a:latin typeface="Verdana" panose="020B0604030504040204" pitchFamily="34" charset="0"/>
+                <a:ea typeface="Verdana" panose="020B0604030504040204" pitchFamily="34" charset="0"/>
+              </a:rPr>
+              <a:t>Engenharia de Software</a:t>
+            </a:r>
+            <a:r>
+              <a:rPr lang="pt-BR" sz="2400" dirty="0">
+                <a:latin typeface="Verdana" panose="020B0604030504040204" pitchFamily="34" charset="0"/>
+                <a:ea typeface="Verdana" panose="020B0604030504040204" pitchFamily="34" charset="0"/>
+              </a:rPr>
+              <a:t>. Tradução de </a:t>
+            </a:r>
+            <a:r>
+              <a:rPr lang="pt-BR" sz="2400" dirty="0" err="1">
+                <a:latin typeface="Verdana" panose="020B0604030504040204" pitchFamily="34" charset="0"/>
+                <a:ea typeface="Verdana" panose="020B0604030504040204" pitchFamily="34" charset="0"/>
+              </a:rPr>
+              <a:t>Luis</a:t>
+            </a:r>
+            <a:r>
+              <a:rPr lang="pt-BR" sz="2400" dirty="0">
+                <a:latin typeface="Verdana" panose="020B0604030504040204" pitchFamily="34" charset="0"/>
+                <a:ea typeface="Verdana" panose="020B0604030504040204" pitchFamily="34" charset="0"/>
+              </a:rPr>
+              <a:t> Claudio Queiroz (Trad.). 10ª. ed. São Paulo: Pearson </a:t>
+            </a:r>
+            <a:r>
+              <a:rPr lang="pt-BR" sz="2400" dirty="0" err="1">
+                <a:latin typeface="Verdana" panose="020B0604030504040204" pitchFamily="34" charset="0"/>
+                <a:ea typeface="Verdana" panose="020B0604030504040204" pitchFamily="34" charset="0"/>
+              </a:rPr>
+              <a:t>Education</a:t>
+            </a:r>
+            <a:r>
+              <a:rPr lang="pt-BR" sz="2400" dirty="0">
+                <a:latin typeface="Verdana" panose="020B0604030504040204" pitchFamily="34" charset="0"/>
+                <a:ea typeface="Verdana" panose="020B0604030504040204" pitchFamily="34" charset="0"/>
+              </a:rPr>
+              <a:t> do Brasil, 2018. Disponível em: &lt;https://www.facom.ufu.br/~</a:t>
+            </a:r>
+            <a:r>
+              <a:rPr lang="pt-BR" sz="2400" dirty="0" err="1">
+                <a:latin typeface="Verdana" panose="020B0604030504040204" pitchFamily="34" charset="0"/>
+                <a:ea typeface="Verdana" panose="020B0604030504040204" pitchFamily="34" charset="0"/>
+              </a:rPr>
+              <a:t>william</a:t>
+            </a:r>
+            <a:r>
+              <a:rPr lang="pt-BR" sz="2400" dirty="0">
+                <a:latin typeface="Verdana" panose="020B0604030504040204" pitchFamily="34" charset="0"/>
+                <a:ea typeface="Verdana" panose="020B0604030504040204" pitchFamily="34" charset="0"/>
+              </a:rPr>
+              <a:t>/Disciplinas%202018-2/BSI-GSI030-EngenhariaSoftware/Livro/engenhariaSoftwareSommerville.pdf&gt;. Acesso em: 03 Outubro 2025.</a:t>
+            </a:r>
+          </a:p>
+          <a:p>
+            <a:pPr marL="1440000" algn="just"/>
+            <a:endParaRPr lang="en-US" altLang="pt-BR" sz="2400" dirty="0">
+              <a:solidFill>
+                <a:srgbClr val="000000"/>
+              </a:solidFill>
+              <a:latin typeface="Verdana" panose="020B0604030504040204" pitchFamily="34" charset="0"/>
+              <a:ea typeface="Verdana" panose="020B0604030504040204" pitchFamily="34" charset="0"/>
+            </a:endParaRPr>
+          </a:p>
+          <a:p>
+            <a:pPr marL="1440000" algn="just"/>
+            <a:r>
+              <a:rPr lang="pt-BR" sz="2400" dirty="0">
+                <a:latin typeface="Verdana" panose="020B0604030504040204" pitchFamily="34" charset="0"/>
+                <a:ea typeface="Verdana" panose="020B0604030504040204" pitchFamily="34" charset="0"/>
+              </a:rPr>
+              <a:t>VAZQUEZ, Carlos Eduardo; SILVA, José Roberto da. </a:t>
+            </a:r>
+            <a:r>
+              <a:rPr lang="pt-BR" sz="2400" b="1" dirty="0">
+                <a:latin typeface="Verdana" panose="020B0604030504040204" pitchFamily="34" charset="0"/>
+                <a:ea typeface="Verdana" panose="020B0604030504040204" pitchFamily="34" charset="0"/>
+              </a:rPr>
+              <a:t>Engenharia de Requisitos:</a:t>
+            </a:r>
+            <a:r>
+              <a:rPr lang="pt-BR" sz="2400" dirty="0">
+                <a:latin typeface="Verdana" panose="020B0604030504040204" pitchFamily="34" charset="0"/>
+                <a:ea typeface="Verdana" panose="020B0604030504040204" pitchFamily="34" charset="0"/>
+              </a:rPr>
+              <a:t> software orientado ao negócio. 2016. Rio de Janeiro, 2016. Disponível em: &lt;https://www.kufunda.net/</a:t>
+            </a:r>
+            <a:r>
+              <a:rPr lang="pt-BR" sz="2400" dirty="0" err="1">
+                <a:latin typeface="Verdana" panose="020B0604030504040204" pitchFamily="34" charset="0"/>
+                <a:ea typeface="Verdana" panose="020B0604030504040204" pitchFamily="34" charset="0"/>
+              </a:rPr>
+              <a:t>publicdocs</a:t>
+            </a:r>
+            <a:r>
+              <a:rPr lang="pt-BR" sz="2400" dirty="0">
+                <a:latin typeface="Verdana" panose="020B0604030504040204" pitchFamily="34" charset="0"/>
+                <a:ea typeface="Verdana" panose="020B0604030504040204" pitchFamily="34" charset="0"/>
+              </a:rPr>
+              <a:t>/Engenharia%20de%20Requisitos%20software%20orientado%20ao%20neg%C3%B3cio%20(Carlos%20Eduardo%20Vazquez%20etc.).</a:t>
+            </a:r>
+            <a:r>
+              <a:rPr lang="pt-BR" sz="2400" dirty="0" err="1">
+                <a:latin typeface="Verdana" panose="020B0604030504040204" pitchFamily="34" charset="0"/>
+                <a:ea typeface="Verdana" panose="020B0604030504040204" pitchFamily="34" charset="0"/>
+              </a:rPr>
+              <a:t>pdf</a:t>
+            </a:r>
+            <a:r>
+              <a:rPr lang="pt-BR" sz="2400" dirty="0">
+                <a:latin typeface="Verdana" panose="020B0604030504040204" pitchFamily="34" charset="0"/>
+                <a:ea typeface="Verdana" panose="020B0604030504040204" pitchFamily="34" charset="0"/>
+              </a:rPr>
+              <a:t>&gt;. Acesso em: 28 Outubro 2025.</a:t>
+            </a:r>
+          </a:p>
+          <a:p>
+            <a:pPr marL="1440000" algn="just"/>
+            <a:endParaRPr lang="en-US" altLang="pt-BR" sz="2400" dirty="0">
+              <a:solidFill>
+                <a:srgbClr val="000000"/>
+              </a:solidFill>
+              <a:latin typeface="Verdana" panose="020B0604030504040204" pitchFamily="34" charset="0"/>
+              <a:ea typeface="Verdana" panose="020B0604030504040204" pitchFamily="34" charset="0"/>
+            </a:endParaRPr>
+          </a:p>
+          <a:p>
+            <a:pPr marL="1440000" algn="just"/>
+            <a:r>
+              <a:rPr lang="pt-BR" sz="2400" dirty="0">
+                <a:latin typeface="Verdana" panose="020B0604030504040204" pitchFamily="34" charset="0"/>
+                <a:ea typeface="Verdana" panose="020B0604030504040204" pitchFamily="34" charset="0"/>
+              </a:rPr>
+              <a:t>PRESSMAN, Roger S.; MAXIM, Bruce R. </a:t>
+            </a:r>
+            <a:r>
+              <a:rPr lang="pt-BR" sz="2400" b="1" dirty="0">
+                <a:latin typeface="Verdana" panose="020B0604030504040204" pitchFamily="34" charset="0"/>
+                <a:ea typeface="Verdana" panose="020B0604030504040204" pitchFamily="34" charset="0"/>
+              </a:rPr>
+              <a:t>Engenharia de software:</a:t>
+            </a:r>
+            <a:r>
+              <a:rPr lang="pt-BR" sz="2400" dirty="0">
+                <a:latin typeface="Verdana" panose="020B0604030504040204" pitchFamily="34" charset="0"/>
+                <a:ea typeface="Verdana" panose="020B0604030504040204" pitchFamily="34" charset="0"/>
+              </a:rPr>
+              <a:t> uma abordagem profissional [recurso eletrônico]. 2021. Porto Alegre, 2021. Disponível em: &lt;https://analisederequisitos.com.br/</a:t>
+            </a:r>
+            <a:r>
+              <a:rPr lang="pt-BR" sz="2400" dirty="0" err="1">
+                <a:latin typeface="Verdana" panose="020B0604030504040204" pitchFamily="34" charset="0"/>
+                <a:ea typeface="Verdana" panose="020B0604030504040204" pitchFamily="34" charset="0"/>
+              </a:rPr>
+              <a:t>wp-content</a:t>
+            </a:r>
+            <a:r>
+              <a:rPr lang="pt-BR" sz="2400" dirty="0">
+                <a:latin typeface="Verdana" panose="020B0604030504040204" pitchFamily="34" charset="0"/>
+                <a:ea typeface="Verdana" panose="020B0604030504040204" pitchFamily="34" charset="0"/>
+              </a:rPr>
+              <a:t>/uploads/2024/02/engenharia-de-software-pressman-9-edicao-portugues.pdf&gt;. Acesso em: 30 Outubro 2025.</a:t>
+            </a:r>
           </a:p>
         </p:txBody>
       </p:sp>
@@ -7951,15 +8133,15 @@
           <p:nvPr/>
         </p:nvPicPr>
         <p:blipFill>
-          <a:blip r:embed="rId4"/>
+          <a:blip r:embed="rId5"/>
           <a:stretch>
             <a:fillRect/>
           </a:stretch>
         </p:blipFill>
         <p:spPr>
           <a:xfrm>
-            <a:off x="15544800" y="33364666"/>
-            <a:ext cx="1143000" cy="1668873"/>
+            <a:off x="15011399" y="32082855"/>
+            <a:ext cx="1207769" cy="1668873"/>
           </a:xfrm>
           <a:prstGeom prst="rect">
             <a:avLst/>
@@ -7981,15 +8163,15 @@
           <p:nvPr/>
         </p:nvPicPr>
         <p:blipFill>
-          <a:blip r:embed="rId5"/>
+          <a:blip r:embed="rId6"/>
           <a:stretch>
             <a:fillRect/>
           </a:stretch>
         </p:blipFill>
         <p:spPr>
           <a:xfrm>
-            <a:off x="15582901" y="35183238"/>
-            <a:ext cx="1143000" cy="1668873"/>
+            <a:off x="15011400" y="35123227"/>
+            <a:ext cx="1207769" cy="1668873"/>
           </a:xfrm>
           <a:prstGeom prst="rect">
             <a:avLst/>
@@ -8011,15 +8193,15 @@
           <p:nvPr/>
         </p:nvPicPr>
         <p:blipFill>
-          <a:blip r:embed="rId6"/>
+          <a:blip r:embed="rId7"/>
           <a:stretch>
             <a:fillRect/>
           </a:stretch>
         </p:blipFill>
         <p:spPr>
           <a:xfrm>
-            <a:off x="15582901" y="36981036"/>
-            <a:ext cx="1104899" cy="1666989"/>
+            <a:off x="15011400" y="37888150"/>
+            <a:ext cx="1207769" cy="1666989"/>
           </a:xfrm>
           <a:prstGeom prst="rect">
             <a:avLst/>
@@ -8028,10 +8210,10 @@
       </p:pic>
       <p:pic>
         <p:nvPicPr>
-          <p:cNvPr id="8" name="Imagem 7">
+          <p:cNvPr id="6" name="Imagem 5">
             <a:extLst>
               <a:ext uri="{FF2B5EF4-FFF2-40B4-BE49-F238E27FC236}">
-                <a16:creationId xmlns:a16="http://schemas.microsoft.com/office/drawing/2014/main" id="{3ABB98E4-819B-4723-9302-87447F20A7AF}"/>
+                <a16:creationId xmlns:a16="http://schemas.microsoft.com/office/drawing/2014/main" id="{D97BB9AF-6E4E-404C-894C-AAD88A74CFED}"/>
               </a:ext>
             </a:extLst>
           </p:cNvPr>
@@ -8041,21 +8223,15 @@
           <p:nvPr/>
         </p:nvPicPr>
         <p:blipFill>
-          <a:blip r:embed="rId7">
-            <a:extLst>
-              <a:ext uri="{28A0092B-C50C-407E-A947-70E740481C1C}">
-                <a14:useLocalDpi xmlns:a14="http://schemas.microsoft.com/office/drawing/2010/main" val="0"/>
-              </a:ext>
-            </a:extLst>
-          </a:blip>
+          <a:blip r:embed="rId8"/>
           <a:stretch>
             <a:fillRect/>
           </a:stretch>
         </p:blipFill>
         <p:spPr>
           <a:xfrm>
-            <a:off x="14862567" y="5563118"/>
-            <a:ext cx="12450763" cy="5399003"/>
+            <a:off x="15011400" y="17529556"/>
+            <a:ext cx="12013566" cy="6308149"/>
           </a:xfrm>
           <a:prstGeom prst="rect">
             <a:avLst/>
@@ -8067,7 +8243,7 @@
           <p:cNvPr id="10" name="Imagem 9">
             <a:extLst>
               <a:ext uri="{FF2B5EF4-FFF2-40B4-BE49-F238E27FC236}">
-                <a16:creationId xmlns:a16="http://schemas.microsoft.com/office/drawing/2014/main" id="{C46CF416-7342-4610-8A28-23E10B2F104D}"/>
+                <a16:creationId xmlns:a16="http://schemas.microsoft.com/office/drawing/2014/main" id="{C49763CD-FFD2-4BAD-A761-1FDD7E4B4786}"/>
               </a:ext>
             </a:extLst>
           </p:cNvPr>
@@ -8077,93 +8253,15 @@
           <p:nvPr/>
         </p:nvPicPr>
         <p:blipFill>
-          <a:blip r:embed="rId8">
-            <a:extLst>
-              <a:ext uri="{28A0092B-C50C-407E-A947-70E740481C1C}">
-                <a14:useLocalDpi xmlns:a14="http://schemas.microsoft.com/office/drawing/2010/main" val="0"/>
-              </a:ext>
-            </a:extLst>
-          </a:blip>
+          <a:blip r:embed="rId9"/>
           <a:stretch>
             <a:fillRect/>
           </a:stretch>
         </p:blipFill>
         <p:spPr>
           <a:xfrm>
-            <a:off x="15301915" y="20303093"/>
-            <a:ext cx="5242764" cy="5242764"/>
-          </a:xfrm>
-          <a:prstGeom prst="rect">
-            <a:avLst/>
-          </a:prstGeom>
-        </p:spPr>
-      </p:pic>
-      <p:pic>
-        <p:nvPicPr>
-          <p:cNvPr id="12" name="Imagem 11">
-            <a:extLst>
-              <a:ext uri="{FF2B5EF4-FFF2-40B4-BE49-F238E27FC236}">
-                <a16:creationId xmlns:a16="http://schemas.microsoft.com/office/drawing/2014/main" id="{678DB3E3-8A48-4383-A62D-B2C8F0522D6F}"/>
-              </a:ext>
-            </a:extLst>
-          </p:cNvPr>
-          <p:cNvPicPr>
-            <a:picLocks noChangeAspect="1"/>
-          </p:cNvPicPr>
-          <p:nvPr/>
-        </p:nvPicPr>
-        <p:blipFill>
-          <a:blip r:embed="rId9">
-            <a:extLst>
-              <a:ext uri="{28A0092B-C50C-407E-A947-70E740481C1C}">
-                <a14:useLocalDpi xmlns:a14="http://schemas.microsoft.com/office/drawing/2010/main" val="0"/>
-              </a:ext>
-            </a:extLst>
-          </a:blip>
-          <a:stretch>
-            <a:fillRect/>
-          </a:stretch>
-        </p:blipFill>
-        <p:spPr>
-          <a:xfrm>
-            <a:off x="1333500" y="25193888"/>
-            <a:ext cx="11830050" cy="7399864"/>
-          </a:xfrm>
-          <a:prstGeom prst="rect">
-            <a:avLst/>
-          </a:prstGeom>
-        </p:spPr>
-      </p:pic>
-      <p:pic>
-        <p:nvPicPr>
-          <p:cNvPr id="14" name="Imagem 13">
-            <a:extLst>
-              <a:ext uri="{FF2B5EF4-FFF2-40B4-BE49-F238E27FC236}">
-                <a16:creationId xmlns:a16="http://schemas.microsoft.com/office/drawing/2014/main" id="{3486FB90-BE5E-4BD5-A987-BDFA3E271583}"/>
-              </a:ext>
-            </a:extLst>
-          </p:cNvPr>
-          <p:cNvPicPr>
-            <a:picLocks noChangeAspect="1"/>
-          </p:cNvPicPr>
-          <p:nvPr/>
-        </p:nvPicPr>
-        <p:blipFill>
-          <a:blip r:embed="rId10">
-            <a:extLst>
-              <a:ext uri="{28A0092B-C50C-407E-A947-70E740481C1C}">
-                <a14:useLocalDpi xmlns:a14="http://schemas.microsoft.com/office/drawing/2010/main" val="0"/>
-              </a:ext>
-            </a:extLst>
-          </a:blip>
-          <a:stretch>
-            <a:fillRect/>
-          </a:stretch>
-        </p:blipFill>
-        <p:spPr>
-          <a:xfrm>
-            <a:off x="22070566" y="20303093"/>
-            <a:ext cx="5242764" cy="5221450"/>
+            <a:off x="1395411" y="25083438"/>
+            <a:ext cx="11939587" cy="7458623"/>
           </a:xfrm>
           <a:prstGeom prst="rect">
             <a:avLst/>

</xml_diff>